<commit_message>
Fehler in E/A Folie
</commit_message>
<xml_diff>
--- a/02_Variablen/02_EinAusgabe.pptx
+++ b/02_Variablen/02_EinAusgabe.pptx
@@ -290,7 +290,7 @@
               <a:pPr>
                 <a:defRPr/>
               </a:pPr>
-              <a:t>17.09.2021</a:t>
+              <a:t>28.09.2021</a:t>
             </a:fld>
             <a:endParaRPr lang="de-AT"/>
           </a:p>
@@ -505,7 +505,7 @@
               <a:pPr>
                 <a:defRPr/>
               </a:pPr>
-              <a:t>17.09.2021</a:t>
+              <a:t>28.09.2021</a:t>
             </a:fld>
             <a:endParaRPr lang="de-AT"/>
           </a:p>
@@ -4292,7 +4292,7 @@
             <a:fld id="{ABC9E1A3-5F60-4045-A7A5-F47B61D1FECD}" type="datetimeFigureOut">
               <a:rPr lang="de-AT" smtClean="0"/>
               <a:pPr/>
-              <a:t>17.09.2021</a:t>
+              <a:t>28.09.2021</a:t>
             </a:fld>
             <a:endParaRPr lang="de-AT"/>
           </a:p>
@@ -4492,7 +4492,7 @@
             <a:fld id="{ABC9E1A3-5F60-4045-A7A5-F47B61D1FECD}" type="datetimeFigureOut">
               <a:rPr lang="de-AT" smtClean="0"/>
               <a:pPr/>
-              <a:t>17.09.2021</a:t>
+              <a:t>28.09.2021</a:t>
             </a:fld>
             <a:endParaRPr lang="de-AT"/>
           </a:p>
@@ -8648,10 +8648,6 @@
               </a:rPr>
               <a:t>;</a:t>
             </a:r>
-            <a:r>
-              <a:rPr lang="de-AT" altLang="de-DE" sz="2200" dirty="0"/>
-              <a:t/>
-            </a:r>
             <a:br>
               <a:rPr lang="de-AT" altLang="de-DE" sz="2200" dirty="0"/>
             </a:br>
@@ -8983,86 +8979,271 @@
             <a:endParaRPr lang="en-US" dirty="0"/>
           </a:p>
           <a:p>
+            <a:pPr marL="0" lvl="0" indent="0">
+              <a:buNone/>
+              <a:defRPr sz="1800"/>
+            </a:pPr>
+            <a:endParaRPr lang="de-AT" sz="1800" dirty="0">
+              <a:latin typeface="Courier New" panose="02070309020205020404" pitchFamily="49" charset="0"/>
+              <a:ea typeface="Monaco"/>
+              <a:cs typeface="Courier New" panose="02070309020205020404" pitchFamily="49" charset="0"/>
+              <a:sym typeface="Monaco"/>
+            </a:endParaRPr>
+          </a:p>
+          <a:p>
+            <a:pPr marL="0" lvl="0" indent="0">
+              <a:buNone/>
+              <a:defRPr sz="1800"/>
+            </a:pPr>
+            <a:r>
+              <a:rPr lang="de-AT" sz="1800" dirty="0" err="1">
+                <a:latin typeface="Courier New" panose="02070309020205020404" pitchFamily="49" charset="0"/>
+                <a:ea typeface="Monaco"/>
+                <a:cs typeface="Courier New" panose="02070309020205020404" pitchFamily="49" charset="0"/>
+                <a:sym typeface="Monaco"/>
+              </a:rPr>
+              <a:t>Console.Write</a:t>
+            </a:r>
+            <a:r>
+              <a:rPr lang="de-AT" sz="1800" dirty="0">
+                <a:latin typeface="Courier New" panose="02070309020205020404" pitchFamily="49" charset="0"/>
+                <a:ea typeface="Monaco"/>
+                <a:cs typeface="Courier New" panose="02070309020205020404" pitchFamily="49" charset="0"/>
+                <a:sym typeface="Monaco"/>
+              </a:rPr>
+              <a:t>(</a:t>
+            </a:r>
+            <a:r>
+              <a:rPr lang="en-US" altLang="de-DE" sz="1800" dirty="0"/>
+              <a:t>"</a:t>
+            </a:r>
+            <a:r>
+              <a:rPr lang="de-AT" sz="1800" dirty="0">
+                <a:latin typeface="Courier New" panose="02070309020205020404" pitchFamily="49" charset="0"/>
+                <a:ea typeface="Monaco"/>
+                <a:cs typeface="Courier New" panose="02070309020205020404" pitchFamily="49" charset="0"/>
+                <a:sym typeface="Monaco"/>
+              </a:rPr>
+              <a:t>Bitte geben sie eine Zahl ein: </a:t>
+            </a:r>
+            <a:r>
+              <a:rPr lang="en-US" altLang="de-DE" sz="1800" dirty="0"/>
+              <a:t>"</a:t>
+            </a:r>
+            <a:r>
+              <a:rPr lang="de-AT" sz="1800" dirty="0">
+                <a:latin typeface="Courier New" panose="02070309020205020404" pitchFamily="49" charset="0"/>
+                <a:ea typeface="Monaco"/>
+                <a:cs typeface="Courier New" panose="02070309020205020404" pitchFamily="49" charset="0"/>
+                <a:sym typeface="Monaco"/>
+              </a:rPr>
+              <a:t>);</a:t>
+            </a:r>
+          </a:p>
+          <a:p>
+            <a:pPr marL="0" lvl="0" indent="0">
+              <a:buNone/>
+              <a:defRPr sz="1800"/>
+            </a:pPr>
+            <a:r>
+              <a:rPr lang="de-AT" sz="1800" dirty="0" err="1">
+                <a:latin typeface="Courier New" panose="02070309020205020404" pitchFamily="49" charset="0"/>
+                <a:ea typeface="Monaco"/>
+                <a:cs typeface="Courier New" panose="02070309020205020404" pitchFamily="49" charset="0"/>
+                <a:sym typeface="Monaco"/>
+              </a:rPr>
+              <a:t>string</a:t>
+            </a:r>
+            <a:r>
+              <a:rPr lang="de-AT" sz="1800" dirty="0">
+                <a:latin typeface="Courier New" panose="02070309020205020404" pitchFamily="49" charset="0"/>
+                <a:ea typeface="Monaco"/>
+                <a:cs typeface="Courier New" panose="02070309020205020404" pitchFamily="49" charset="0"/>
+                <a:sym typeface="Monaco"/>
+              </a:rPr>
+              <a:t> </a:t>
+            </a:r>
+            <a:r>
+              <a:rPr lang="de-AT" sz="1800" dirty="0" err="1">
+                <a:latin typeface="Courier New" panose="02070309020205020404" pitchFamily="49" charset="0"/>
+                <a:ea typeface="Monaco"/>
+                <a:cs typeface="Courier New" panose="02070309020205020404" pitchFamily="49" charset="0"/>
+                <a:sym typeface="Monaco"/>
+              </a:rPr>
+              <a:t>userInput</a:t>
+            </a:r>
+            <a:r>
+              <a:rPr lang="de-AT" sz="1800" dirty="0">
+                <a:latin typeface="Courier New" panose="02070309020205020404" pitchFamily="49" charset="0"/>
+                <a:ea typeface="Monaco"/>
+                <a:cs typeface="Courier New" panose="02070309020205020404" pitchFamily="49" charset="0"/>
+                <a:sym typeface="Monaco"/>
+              </a:rPr>
+              <a:t> = </a:t>
+            </a:r>
+            <a:r>
+              <a:rPr lang="de-AT" sz="1800" dirty="0" err="1">
+                <a:latin typeface="Courier New" panose="02070309020205020404" pitchFamily="49" charset="0"/>
+                <a:ea typeface="Monaco"/>
+                <a:cs typeface="Courier New" panose="02070309020205020404" pitchFamily="49" charset="0"/>
+                <a:sym typeface="Monaco"/>
+              </a:rPr>
+              <a:t>Console.ReadLine</a:t>
+            </a:r>
+            <a:r>
+              <a:rPr lang="de-AT" sz="1800" dirty="0">
+                <a:latin typeface="Courier New" panose="02070309020205020404" pitchFamily="49" charset="0"/>
+                <a:ea typeface="Monaco"/>
+                <a:cs typeface="Courier New" panose="02070309020205020404" pitchFamily="49" charset="0"/>
+                <a:sym typeface="Monaco"/>
+              </a:rPr>
+              <a:t>();</a:t>
+            </a:r>
+          </a:p>
+          <a:p>
+            <a:pPr marL="0" lvl="0" indent="0">
+              <a:buNone/>
+              <a:defRPr sz="1800"/>
+            </a:pPr>
+            <a:endParaRPr lang="de-AT" sz="1800" dirty="0">
+              <a:latin typeface="Courier New" panose="02070309020205020404" pitchFamily="49" charset="0"/>
+              <a:ea typeface="Monaco"/>
+              <a:cs typeface="Courier New" panose="02070309020205020404" pitchFamily="49" charset="0"/>
+              <a:sym typeface="Monaco"/>
+            </a:endParaRPr>
+          </a:p>
+          <a:p>
+            <a:pPr marL="0" lvl="0" indent="0">
+              <a:buNone/>
+              <a:defRPr sz="1800"/>
+            </a:pPr>
+            <a:r>
+              <a:rPr lang="de-AT" sz="1800" dirty="0" err="1">
+                <a:latin typeface="Courier New" panose="02070309020205020404" pitchFamily="49" charset="0"/>
+                <a:cs typeface="Courier New" panose="02070309020205020404" pitchFamily="49" charset="0"/>
+              </a:rPr>
+              <a:t>int</a:t>
+            </a:r>
+            <a:r>
+              <a:rPr lang="de-AT" sz="1800" dirty="0">
+                <a:latin typeface="Courier New" panose="02070309020205020404" pitchFamily="49" charset="0"/>
+                <a:cs typeface="Courier New" panose="02070309020205020404" pitchFamily="49" charset="0"/>
+              </a:rPr>
+              <a:t> </a:t>
+            </a:r>
+            <a:r>
+              <a:rPr lang="de-AT" sz="1800" dirty="0" err="1">
+                <a:latin typeface="Courier New" panose="02070309020205020404" pitchFamily="49" charset="0"/>
+                <a:cs typeface="Courier New" panose="02070309020205020404" pitchFamily="49" charset="0"/>
+              </a:rPr>
+              <a:t>value</a:t>
+            </a:r>
+            <a:r>
+              <a:rPr lang="de-AT" sz="1800" dirty="0">
+                <a:latin typeface="Courier New" panose="02070309020205020404" pitchFamily="49" charset="0"/>
+                <a:cs typeface="Courier New" panose="02070309020205020404" pitchFamily="49" charset="0"/>
+              </a:rPr>
+              <a:t> = </a:t>
+            </a:r>
+            <a:r>
+              <a:rPr lang="de-AT" sz="1800" b="1" dirty="0">
+                <a:latin typeface="Courier New" panose="02070309020205020404" pitchFamily="49" charset="0"/>
+                <a:cs typeface="Courier New" panose="02070309020205020404" pitchFamily="49" charset="0"/>
+              </a:rPr>
+              <a:t>Convert.ToInt32</a:t>
+            </a:r>
+            <a:r>
+              <a:rPr lang="de-AT" sz="1800" dirty="0">
+                <a:latin typeface="Courier New" panose="02070309020205020404" pitchFamily="49" charset="0"/>
+                <a:cs typeface="Courier New" panose="02070309020205020404" pitchFamily="49" charset="0"/>
+              </a:rPr>
+              <a:t>(</a:t>
+            </a:r>
+            <a:r>
+              <a:rPr lang="de-AT" sz="1800" dirty="0" err="1">
+                <a:latin typeface="Courier New" panose="02070309020205020404" pitchFamily="49" charset="0"/>
+                <a:cs typeface="Courier New" panose="02070309020205020404" pitchFamily="49" charset="0"/>
+              </a:rPr>
+              <a:t>userInput</a:t>
+            </a:r>
+            <a:r>
+              <a:rPr lang="de-AT" sz="1800" dirty="0">
+                <a:latin typeface="Courier New" panose="02070309020205020404" pitchFamily="49" charset="0"/>
+                <a:cs typeface="Courier New" panose="02070309020205020404" pitchFamily="49" charset="0"/>
+              </a:rPr>
+              <a:t>);</a:t>
+            </a:r>
+          </a:p>
+          <a:p>
+            <a:pPr marL="0" lvl="0" indent="0">
+              <a:buNone/>
+              <a:defRPr sz="1800"/>
+            </a:pPr>
+            <a:endParaRPr lang="de-AT" sz="1800" dirty="0">
+              <a:latin typeface="Courier New" panose="02070309020205020404" pitchFamily="49" charset="0"/>
+              <a:cs typeface="Courier New" panose="02070309020205020404" pitchFamily="49" charset="0"/>
+            </a:endParaRPr>
+          </a:p>
+          <a:p>
+            <a:pPr marL="0" lvl="0" indent="0">
+              <a:buNone/>
+              <a:defRPr sz="1800"/>
+            </a:pPr>
+            <a:r>
+              <a:rPr lang="de-AT" sz="1800" dirty="0">
+                <a:latin typeface="Courier New" panose="02070309020205020404" pitchFamily="49" charset="0"/>
+                <a:cs typeface="Courier New" panose="02070309020205020404" pitchFamily="49" charset="0"/>
+              </a:rPr>
+              <a:t>double </a:t>
+            </a:r>
+            <a:r>
+              <a:rPr lang="de-AT" sz="1800" dirty="0" err="1">
+                <a:latin typeface="Courier New" panose="02070309020205020404" pitchFamily="49" charset="0"/>
+                <a:cs typeface="Courier New" panose="02070309020205020404" pitchFamily="49" charset="0"/>
+              </a:rPr>
+              <a:t>decimalValue</a:t>
+            </a:r>
+            <a:r>
+              <a:rPr lang="de-AT" sz="1800" dirty="0">
+                <a:latin typeface="Courier New" panose="02070309020205020404" pitchFamily="49" charset="0"/>
+                <a:cs typeface="Courier New" panose="02070309020205020404" pitchFamily="49" charset="0"/>
+              </a:rPr>
+              <a:t> = </a:t>
+            </a:r>
+            <a:r>
+              <a:rPr lang="de-AT" sz="1800" b="1" dirty="0" err="1">
+                <a:latin typeface="Courier New" panose="02070309020205020404" pitchFamily="49" charset="0"/>
+                <a:cs typeface="Courier New" panose="02070309020205020404" pitchFamily="49" charset="0"/>
+              </a:rPr>
+              <a:t>Convert.ToDouble</a:t>
+            </a:r>
+            <a:r>
+              <a:rPr lang="de-AT" sz="1800" dirty="0">
+                <a:latin typeface="Courier New" panose="02070309020205020404" pitchFamily="49" charset="0"/>
+                <a:cs typeface="Courier New" panose="02070309020205020404" pitchFamily="49" charset="0"/>
+              </a:rPr>
+              <a:t>(</a:t>
+            </a:r>
+            <a:r>
+              <a:rPr lang="de-AT" sz="1800" dirty="0" err="1">
+                <a:latin typeface="Courier New" panose="02070309020205020404" pitchFamily="49" charset="0"/>
+                <a:cs typeface="Courier New" panose="02070309020205020404" pitchFamily="49" charset="0"/>
+              </a:rPr>
+              <a:t>userInput</a:t>
+            </a:r>
+            <a:r>
+              <a:rPr lang="de-AT" sz="1800" dirty="0">
+                <a:latin typeface="Courier New" panose="02070309020205020404" pitchFamily="49" charset="0"/>
+                <a:cs typeface="Courier New" panose="02070309020205020404" pitchFamily="49" charset="0"/>
+              </a:rPr>
+              <a:t>);</a:t>
+            </a:r>
+          </a:p>
+          <a:p>
             <a:pPr lvl="0">
               <a:defRPr sz="1800"/>
             </a:pPr>
-            <a:r>
-              <a:rPr lang="de-AT" sz="1800" dirty="0" err="1">
-                <a:latin typeface="Monaco"/>
-                <a:ea typeface="Monaco"/>
-                <a:cs typeface="Monaco"/>
-                <a:sym typeface="Monaco"/>
-              </a:rPr>
-              <a:t>string</a:t>
-            </a:r>
-            <a:r>
-              <a:rPr lang="de-AT" sz="1800" dirty="0">
-                <a:latin typeface="Monaco"/>
-                <a:ea typeface="Monaco"/>
-                <a:cs typeface="Monaco"/>
-                <a:sym typeface="Monaco"/>
-              </a:rPr>
-              <a:t> </a:t>
-            </a:r>
-            <a:r>
-              <a:rPr lang="de-AT" sz="1800" dirty="0" err="1">
-                <a:latin typeface="Monaco"/>
-                <a:ea typeface="Monaco"/>
-                <a:cs typeface="Monaco"/>
-                <a:sym typeface="Monaco"/>
-              </a:rPr>
-              <a:t>userInput</a:t>
-            </a:r>
-            <a:r>
-              <a:rPr lang="de-AT" sz="1800" dirty="0">
-                <a:latin typeface="Monaco"/>
-                <a:ea typeface="Monaco"/>
-                <a:cs typeface="Monaco"/>
-                <a:sym typeface="Monaco"/>
-              </a:rPr>
-              <a:t>;</a:t>
-            </a:r>
-          </a:p>
-          <a:p>
-            <a:pPr lvl="0">
-              <a:defRPr sz="1800"/>
-            </a:pPr>
-            <a:r>
-              <a:rPr lang="de-AT" sz="1800" dirty="0" err="1">
-                <a:latin typeface="Monaco"/>
-                <a:ea typeface="Monaco"/>
-                <a:cs typeface="Monaco"/>
-                <a:sym typeface="Monaco"/>
-              </a:rPr>
-              <a:t>userInput</a:t>
-            </a:r>
-            <a:r>
-              <a:rPr lang="de-AT" sz="1800" dirty="0">
-                <a:latin typeface="Monaco"/>
-                <a:ea typeface="Monaco"/>
-                <a:cs typeface="Monaco"/>
-                <a:sym typeface="Monaco"/>
-              </a:rPr>
-              <a:t> = </a:t>
-            </a:r>
-            <a:r>
-              <a:rPr lang="de-AT" sz="1800" dirty="0" err="1">
-                <a:latin typeface="Monaco"/>
-                <a:ea typeface="Monaco"/>
-                <a:cs typeface="Monaco"/>
-                <a:sym typeface="Monaco"/>
-              </a:rPr>
-              <a:t>Console.ReadLine</a:t>
-            </a:r>
-            <a:r>
-              <a:rPr lang="de-AT" sz="1800" dirty="0">
-                <a:latin typeface="Monaco"/>
-                <a:ea typeface="Monaco"/>
-                <a:cs typeface="Monaco"/>
-                <a:sym typeface="Monaco"/>
-              </a:rPr>
-              <a:t>();</a:t>
-            </a:r>
+            <a:endParaRPr lang="de-AT" sz="1800" dirty="0"/>
           </a:p>
           <a:p>
             <a:pPr lvl="0">
@@ -9079,125 +9260,6 @@
             <a:pPr lvl="0">
               <a:defRPr sz="1800"/>
             </a:pPr>
-            <a:endParaRPr lang="de-AT" sz="1800" dirty="0">
-              <a:latin typeface="Monaco"/>
-              <a:ea typeface="Monaco"/>
-              <a:cs typeface="Monaco"/>
-              <a:sym typeface="Monaco"/>
-            </a:endParaRPr>
-          </a:p>
-          <a:p>
-            <a:pPr lvl="0">
-              <a:defRPr sz="1800"/>
-            </a:pPr>
-            <a:endParaRPr lang="de-AT" sz="1800" dirty="0">
-              <a:latin typeface="Monaco"/>
-              <a:ea typeface="Monaco"/>
-              <a:cs typeface="Monaco"/>
-              <a:sym typeface="Monaco"/>
-            </a:endParaRPr>
-          </a:p>
-          <a:p>
-            <a:pPr lvl="0">
-              <a:defRPr sz="1800"/>
-            </a:pPr>
-            <a:r>
-              <a:rPr lang="de-AT" sz="1800" dirty="0" err="1"/>
-              <a:t>int</a:t>
-            </a:r>
-            <a:r>
-              <a:rPr lang="de-AT" sz="1800" dirty="0"/>
-              <a:t> </a:t>
-            </a:r>
-            <a:r>
-              <a:rPr lang="de-AT" sz="1800" dirty="0" err="1"/>
-              <a:t>value</a:t>
-            </a:r>
-            <a:r>
-              <a:rPr lang="de-AT" sz="1800" dirty="0"/>
-              <a:t> = Convert.ToInt32(</a:t>
-            </a:r>
-            <a:r>
-              <a:rPr lang="de-AT" sz="1800" dirty="0" err="1"/>
-              <a:t>userInput</a:t>
-            </a:r>
-            <a:r>
-              <a:rPr lang="de-AT" sz="1800" dirty="0"/>
-              <a:t>);</a:t>
-            </a:r>
-          </a:p>
-          <a:p>
-            <a:pPr lvl="0">
-              <a:defRPr sz="1800"/>
-            </a:pPr>
-            <a:endParaRPr lang="de-AT" sz="1800" dirty="0"/>
-          </a:p>
-          <a:p>
-            <a:pPr lvl="0">
-              <a:defRPr sz="1800"/>
-            </a:pPr>
-            <a:endParaRPr lang="de-AT" sz="1800" dirty="0"/>
-          </a:p>
-          <a:p>
-            <a:pPr lvl="0">
-              <a:defRPr sz="1800"/>
-            </a:pPr>
-            <a:endParaRPr lang="de-AT" sz="1800" dirty="0"/>
-          </a:p>
-          <a:p>
-            <a:pPr lvl="0">
-              <a:defRPr sz="1800"/>
-            </a:pPr>
-            <a:r>
-              <a:rPr lang="de-AT" sz="1800" dirty="0"/>
-              <a:t>double </a:t>
-            </a:r>
-            <a:r>
-              <a:rPr lang="de-AT" sz="1800" dirty="0" err="1"/>
-              <a:t>decimalValue</a:t>
-            </a:r>
-            <a:r>
-              <a:rPr lang="de-AT" sz="1800" dirty="0"/>
-              <a:t> = </a:t>
-            </a:r>
-            <a:r>
-              <a:rPr lang="de-AT" sz="1800" dirty="0" err="1"/>
-              <a:t>Convert.ToDouble</a:t>
-            </a:r>
-            <a:r>
-              <a:rPr lang="de-AT" sz="1800" dirty="0"/>
-              <a:t>(</a:t>
-            </a:r>
-            <a:r>
-              <a:rPr lang="de-AT" sz="1800" dirty="0" err="1"/>
-              <a:t>userInput</a:t>
-            </a:r>
-            <a:r>
-              <a:rPr lang="de-AT" sz="1800" dirty="0"/>
-              <a:t>);</a:t>
-            </a:r>
-          </a:p>
-          <a:p>
-            <a:pPr lvl="0">
-              <a:defRPr sz="1800"/>
-            </a:pPr>
-            <a:endParaRPr lang="de-AT" sz="1800" dirty="0"/>
-          </a:p>
-          <a:p>
-            <a:pPr lvl="0">
-              <a:defRPr sz="1800"/>
-            </a:pPr>
-            <a:endParaRPr lang="de-AT" sz="1800" dirty="0">
-              <a:latin typeface="Monaco"/>
-              <a:ea typeface="Monaco"/>
-              <a:cs typeface="Monaco"/>
-              <a:sym typeface="Monaco"/>
-            </a:endParaRPr>
-          </a:p>
-          <a:p>
-            <a:pPr lvl="0">
-              <a:defRPr sz="1800"/>
-            </a:pPr>
             <a:endParaRPr lang="en-US" dirty="0"/>
           </a:p>
           <a:p>
@@ -9205,94 +9267,6 @@
           </a:p>
         </p:txBody>
       </p:sp>
-      <p:grpSp>
-        <p:nvGrpSpPr>
-          <p:cNvPr id="7" name="Gruppieren 6"/>
-          <p:cNvGrpSpPr/>
-          <p:nvPr/>
-        </p:nvGrpSpPr>
-        <p:grpSpPr>
-          <a:xfrm>
-            <a:off x="3059832" y="1196752"/>
-            <a:ext cx="3168352" cy="504056"/>
-            <a:chOff x="5436096" y="2132856"/>
-            <a:chExt cx="2448272" cy="504056"/>
-          </a:xfrm>
-        </p:grpSpPr>
-        <p:sp>
-          <p:nvSpPr>
-            <p:cNvPr id="8" name="Ovale Legende 7"/>
-            <p:cNvSpPr/>
-            <p:nvPr/>
-          </p:nvSpPr>
-          <p:spPr>
-            <a:xfrm>
-              <a:off x="5436096" y="2132856"/>
-              <a:ext cx="2448272" cy="504056"/>
-            </a:xfrm>
-            <a:prstGeom prst="wedgeEllipseCallout">
-              <a:avLst/>
-            </a:prstGeom>
-          </p:spPr>
-          <p:style>
-            <a:lnRef idx="2">
-              <a:schemeClr val="accent1">
-                <a:shade val="50000"/>
-              </a:schemeClr>
-            </a:lnRef>
-            <a:fillRef idx="1">
-              <a:schemeClr val="accent1"/>
-            </a:fillRef>
-            <a:effectRef idx="0">
-              <a:schemeClr val="accent1"/>
-            </a:effectRef>
-            <a:fontRef idx="minor">
-              <a:schemeClr val="lt1"/>
-            </a:fontRef>
-          </p:style>
-          <p:txBody>
-            <a:bodyPr rtlCol="0" anchor="ctr"/>
-            <a:lstStyle/>
-            <a:p>
-              <a:pPr algn="ctr"/>
-              <a:endParaRPr lang="de-AT"/>
-            </a:p>
-          </p:txBody>
-        </p:sp>
-        <p:sp>
-          <p:nvSpPr>
-            <p:cNvPr id="9" name="Textfeld 8"/>
-            <p:cNvSpPr txBox="1"/>
-            <p:nvPr/>
-          </p:nvSpPr>
-          <p:spPr>
-            <a:xfrm>
-              <a:off x="5491739" y="2257127"/>
-              <a:ext cx="2392629" cy="307777"/>
-            </a:xfrm>
-            <a:prstGeom prst="rect">
-              <a:avLst/>
-            </a:prstGeom>
-            <a:noFill/>
-          </p:spPr>
-          <p:txBody>
-            <a:bodyPr wrap="square" rtlCol="0">
-              <a:spAutoFit/>
-            </a:bodyPr>
-            <a:lstStyle/>
-            <a:p>
-              <a:r>
-                <a:rPr lang="de-AT" sz="1400" dirty="0">
-                  <a:solidFill>
-                    <a:schemeClr val="bg1"/>
-                  </a:solidFill>
-                </a:rPr>
-                <a:t>Frage: Wie liest man eine Zahl ein?</a:t>
-              </a:r>
-            </a:p>
-          </p:txBody>
-        </p:sp>
-      </p:grpSp>
     </p:spTree>
     <p:extLst>
       <p:ext uri="{BB962C8B-B14F-4D97-AF65-F5344CB8AC3E}">
@@ -9354,7 +9328,7 @@
           <p:cNvPr id="5" name="Inhaltsplatzhalter 4">
             <a:extLst>
               <a:ext uri="{FF2B5EF4-FFF2-40B4-BE49-F238E27FC236}">
-                <a16:creationId xmlns:a16="http://schemas.microsoft.com/office/drawing/2014/main" xmlns="" id="{2D9B9169-075B-4C62-B506-BD5986C448E5}"/>
+                <a16:creationId xmlns:a16="http://schemas.microsoft.com/office/drawing/2014/main" id="{2D9B9169-075B-4C62-B506-BD5986C448E5}"/>
               </a:ext>
             </a:extLst>
           </p:cNvPr>
@@ -9370,40 +9344,641 @@
           <a:bodyPr/>
           <a:lstStyle/>
           <a:p>
-            <a:endParaRPr lang="de-AT"/>
+            <a:pPr marL="0" indent="0">
+              <a:buNone/>
+            </a:pPr>
+            <a:r>
+              <a:rPr lang="de-AT" sz="1800" dirty="0" err="1">
+                <a:solidFill>
+                  <a:srgbClr val="000000"/>
+                </a:solidFill>
+                <a:latin typeface="Consolas" panose="020B0609020204030204" pitchFamily="49" charset="0"/>
+              </a:rPr>
+              <a:t>Console.Write</a:t>
+            </a:r>
+            <a:r>
+              <a:rPr lang="de-AT" sz="1800" dirty="0">
+                <a:solidFill>
+                  <a:srgbClr val="000000"/>
+                </a:solidFill>
+                <a:latin typeface="Consolas" panose="020B0609020204030204" pitchFamily="49" charset="0"/>
+              </a:rPr>
+              <a:t>(</a:t>
+            </a:r>
+            <a:r>
+              <a:rPr lang="de-AT" sz="1800" dirty="0">
+                <a:solidFill>
+                  <a:srgbClr val="A31515"/>
+                </a:solidFill>
+                <a:latin typeface="Consolas" panose="020B0609020204030204" pitchFamily="49" charset="0"/>
+              </a:rPr>
+              <a:t>"Enter </a:t>
+            </a:r>
+            <a:r>
+              <a:rPr lang="de-AT" sz="1800" dirty="0" err="1">
+                <a:solidFill>
+                  <a:srgbClr val="A31515"/>
+                </a:solidFill>
+                <a:latin typeface="Consolas" panose="020B0609020204030204" pitchFamily="49" charset="0"/>
+              </a:rPr>
+              <a:t>numerator</a:t>
+            </a:r>
+            <a:r>
+              <a:rPr lang="de-AT" sz="1800" dirty="0">
+                <a:solidFill>
+                  <a:srgbClr val="A31515"/>
+                </a:solidFill>
+                <a:latin typeface="Consolas" panose="020B0609020204030204" pitchFamily="49" charset="0"/>
+              </a:rPr>
+              <a:t>: "</a:t>
+            </a:r>
+            <a:r>
+              <a:rPr lang="de-AT" sz="1800" dirty="0">
+                <a:solidFill>
+                  <a:srgbClr val="000000"/>
+                </a:solidFill>
+                <a:latin typeface="Consolas" panose="020B0609020204030204" pitchFamily="49" charset="0"/>
+              </a:rPr>
+              <a:t>);</a:t>
+            </a:r>
+          </a:p>
+          <a:p>
+            <a:pPr marL="0" indent="0">
+              <a:buNone/>
+            </a:pPr>
+            <a:r>
+              <a:rPr lang="de-AT" sz="1800" dirty="0" err="1">
+                <a:solidFill>
+                  <a:srgbClr val="0000FF"/>
+                </a:solidFill>
+                <a:latin typeface="Consolas" panose="020B0609020204030204" pitchFamily="49" charset="0"/>
+              </a:rPr>
+              <a:t>string</a:t>
+            </a:r>
+            <a:r>
+              <a:rPr lang="de-AT" sz="1800" dirty="0">
+                <a:solidFill>
+                  <a:srgbClr val="000000"/>
+                </a:solidFill>
+                <a:latin typeface="Consolas" panose="020B0609020204030204" pitchFamily="49" charset="0"/>
+              </a:rPr>
+              <a:t> </a:t>
+            </a:r>
+            <a:r>
+              <a:rPr lang="de-AT" sz="1800" dirty="0" err="1">
+                <a:solidFill>
+                  <a:srgbClr val="000000"/>
+                </a:solidFill>
+                <a:latin typeface="Consolas" panose="020B0609020204030204" pitchFamily="49" charset="0"/>
+              </a:rPr>
+              <a:t>userInput</a:t>
+            </a:r>
+            <a:r>
+              <a:rPr lang="de-AT" sz="1800" dirty="0">
+                <a:solidFill>
+                  <a:srgbClr val="000000"/>
+                </a:solidFill>
+                <a:latin typeface="Consolas" panose="020B0609020204030204" pitchFamily="49" charset="0"/>
+              </a:rPr>
+              <a:t> = </a:t>
+            </a:r>
+            <a:r>
+              <a:rPr lang="de-AT" sz="1800" dirty="0" err="1">
+                <a:solidFill>
+                  <a:srgbClr val="000000"/>
+                </a:solidFill>
+                <a:latin typeface="Consolas" panose="020B0609020204030204" pitchFamily="49" charset="0"/>
+              </a:rPr>
+              <a:t>Console.RealdLine</a:t>
+            </a:r>
+            <a:r>
+              <a:rPr lang="de-AT" sz="1800" dirty="0">
+                <a:solidFill>
+                  <a:srgbClr val="000000"/>
+                </a:solidFill>
+                <a:latin typeface="Consolas" panose="020B0609020204030204" pitchFamily="49" charset="0"/>
+              </a:rPr>
+              <a:t>();</a:t>
+            </a:r>
+          </a:p>
+          <a:p>
+            <a:pPr marL="0" indent="0">
+              <a:buNone/>
+            </a:pPr>
+            <a:r>
+              <a:rPr lang="de-AT" sz="1800" dirty="0">
+                <a:solidFill>
+                  <a:srgbClr val="0000FF"/>
+                </a:solidFill>
+                <a:latin typeface="Consolas" panose="020B0609020204030204" pitchFamily="49" charset="0"/>
+              </a:rPr>
+              <a:t>double</a:t>
+            </a:r>
+            <a:r>
+              <a:rPr lang="de-AT" sz="1800" dirty="0">
+                <a:solidFill>
+                  <a:srgbClr val="000000"/>
+                </a:solidFill>
+                <a:latin typeface="Consolas" panose="020B0609020204030204" pitchFamily="49" charset="0"/>
+              </a:rPr>
+              <a:t> </a:t>
+            </a:r>
+            <a:r>
+              <a:rPr lang="de-AT" sz="1800" dirty="0" err="1">
+                <a:solidFill>
+                  <a:srgbClr val="000000"/>
+                </a:solidFill>
+                <a:latin typeface="Consolas" panose="020B0609020204030204" pitchFamily="49" charset="0"/>
+              </a:rPr>
+              <a:t>numerator</a:t>
+            </a:r>
+            <a:r>
+              <a:rPr lang="de-AT" sz="1800" dirty="0">
+                <a:solidFill>
+                  <a:srgbClr val="000000"/>
+                </a:solidFill>
+                <a:latin typeface="Consolas" panose="020B0609020204030204" pitchFamily="49" charset="0"/>
+              </a:rPr>
+              <a:t> = </a:t>
+            </a:r>
+            <a:r>
+              <a:rPr lang="de-AT" sz="1800" dirty="0" err="1">
+                <a:solidFill>
+                  <a:srgbClr val="000000"/>
+                </a:solidFill>
+                <a:latin typeface="Consolas" panose="020B0609020204030204" pitchFamily="49" charset="0"/>
+              </a:rPr>
+              <a:t>Convert.ToDouble</a:t>
+            </a:r>
+            <a:r>
+              <a:rPr lang="de-AT" sz="1800" dirty="0">
+                <a:solidFill>
+                  <a:srgbClr val="000000"/>
+                </a:solidFill>
+                <a:latin typeface="Consolas" panose="020B0609020204030204" pitchFamily="49" charset="0"/>
+              </a:rPr>
+              <a:t>(</a:t>
+            </a:r>
+            <a:r>
+              <a:rPr lang="de-AT" sz="1800" dirty="0" err="1">
+                <a:solidFill>
+                  <a:srgbClr val="000000"/>
+                </a:solidFill>
+                <a:latin typeface="Consolas" panose="020B0609020204030204" pitchFamily="49" charset="0"/>
+              </a:rPr>
+              <a:t>userInput</a:t>
+            </a:r>
+            <a:r>
+              <a:rPr lang="de-AT" sz="1800" dirty="0">
+                <a:solidFill>
+                  <a:srgbClr val="000000"/>
+                </a:solidFill>
+                <a:latin typeface="Consolas" panose="020B0609020204030204" pitchFamily="49" charset="0"/>
+              </a:rPr>
+              <a:t>);</a:t>
+            </a:r>
+          </a:p>
+          <a:p>
+            <a:pPr marL="0" indent="0">
+              <a:buNone/>
+            </a:pPr>
+            <a:endParaRPr lang="de-AT" sz="1800" dirty="0">
+              <a:solidFill>
+                <a:srgbClr val="000000"/>
+              </a:solidFill>
+              <a:latin typeface="Consolas" panose="020B0609020204030204" pitchFamily="49" charset="0"/>
+            </a:endParaRPr>
+          </a:p>
+          <a:p>
+            <a:pPr marL="0" indent="0">
+              <a:buNone/>
+            </a:pPr>
+            <a:r>
+              <a:rPr lang="de-AT" sz="1800" dirty="0" err="1">
+                <a:solidFill>
+                  <a:srgbClr val="000000"/>
+                </a:solidFill>
+                <a:latin typeface="Consolas" panose="020B0609020204030204" pitchFamily="49" charset="0"/>
+              </a:rPr>
+              <a:t>Console.Write</a:t>
+            </a:r>
+            <a:r>
+              <a:rPr lang="de-AT" sz="1800" dirty="0">
+                <a:solidFill>
+                  <a:srgbClr val="000000"/>
+                </a:solidFill>
+                <a:latin typeface="Consolas" panose="020B0609020204030204" pitchFamily="49" charset="0"/>
+              </a:rPr>
+              <a:t>(</a:t>
+            </a:r>
+            <a:r>
+              <a:rPr lang="de-AT" sz="1800" dirty="0">
+                <a:solidFill>
+                  <a:srgbClr val="A31515"/>
+                </a:solidFill>
+                <a:latin typeface="Consolas" panose="020B0609020204030204" pitchFamily="49" charset="0"/>
+              </a:rPr>
+              <a:t>"Enter </a:t>
+            </a:r>
+            <a:r>
+              <a:rPr lang="de-AT" sz="1800" dirty="0" err="1">
+                <a:solidFill>
+                  <a:srgbClr val="A31515"/>
+                </a:solidFill>
+                <a:latin typeface="Consolas" panose="020B0609020204030204" pitchFamily="49" charset="0"/>
+              </a:rPr>
+              <a:t>denominator</a:t>
+            </a:r>
+            <a:r>
+              <a:rPr lang="de-AT" sz="1800" dirty="0">
+                <a:solidFill>
+                  <a:srgbClr val="A31515"/>
+                </a:solidFill>
+                <a:latin typeface="Consolas" panose="020B0609020204030204" pitchFamily="49" charset="0"/>
+              </a:rPr>
+              <a:t>: "</a:t>
+            </a:r>
+            <a:r>
+              <a:rPr lang="de-AT" sz="1800" dirty="0">
+                <a:solidFill>
+                  <a:srgbClr val="000000"/>
+                </a:solidFill>
+                <a:latin typeface="Consolas" panose="020B0609020204030204" pitchFamily="49" charset="0"/>
+              </a:rPr>
+              <a:t>);</a:t>
+            </a:r>
+          </a:p>
+          <a:p>
+            <a:pPr marL="0" indent="0">
+              <a:buNone/>
+            </a:pPr>
+            <a:r>
+              <a:rPr lang="de-AT" sz="1800" dirty="0" err="1">
+                <a:solidFill>
+                  <a:srgbClr val="000000"/>
+                </a:solidFill>
+                <a:latin typeface="Consolas" panose="020B0609020204030204" pitchFamily="49" charset="0"/>
+              </a:rPr>
+              <a:t>userInput</a:t>
+            </a:r>
+            <a:r>
+              <a:rPr lang="de-AT" sz="1800" dirty="0">
+                <a:solidFill>
+                  <a:srgbClr val="000000"/>
+                </a:solidFill>
+                <a:latin typeface="Consolas" panose="020B0609020204030204" pitchFamily="49" charset="0"/>
+              </a:rPr>
+              <a:t> = </a:t>
+            </a:r>
+            <a:r>
+              <a:rPr lang="de-AT" sz="1800" dirty="0" err="1">
+                <a:solidFill>
+                  <a:srgbClr val="000000"/>
+                </a:solidFill>
+                <a:latin typeface="Consolas" panose="020B0609020204030204" pitchFamily="49" charset="0"/>
+              </a:rPr>
+              <a:t>Console.RealdLine</a:t>
+            </a:r>
+            <a:r>
+              <a:rPr lang="de-AT" sz="1800" dirty="0">
+                <a:solidFill>
+                  <a:srgbClr val="000000"/>
+                </a:solidFill>
+                <a:latin typeface="Consolas" panose="020B0609020204030204" pitchFamily="49" charset="0"/>
+              </a:rPr>
+              <a:t>();</a:t>
+            </a:r>
+          </a:p>
+          <a:p>
+            <a:pPr marL="0" indent="0">
+              <a:buNone/>
+            </a:pPr>
+            <a:r>
+              <a:rPr lang="de-AT" sz="1800" dirty="0">
+                <a:solidFill>
+                  <a:srgbClr val="0000FF"/>
+                </a:solidFill>
+                <a:latin typeface="Consolas" panose="020B0609020204030204" pitchFamily="49" charset="0"/>
+              </a:rPr>
+              <a:t>double</a:t>
+            </a:r>
+            <a:r>
+              <a:rPr lang="de-AT" sz="1800" dirty="0">
+                <a:solidFill>
+                  <a:srgbClr val="000000"/>
+                </a:solidFill>
+                <a:latin typeface="Consolas" panose="020B0609020204030204" pitchFamily="49" charset="0"/>
+              </a:rPr>
+              <a:t> </a:t>
+            </a:r>
+            <a:r>
+              <a:rPr lang="de-AT" sz="1800" dirty="0" err="1">
+                <a:solidFill>
+                  <a:srgbClr val="000000"/>
+                </a:solidFill>
+                <a:latin typeface="Consolas" panose="020B0609020204030204" pitchFamily="49" charset="0"/>
+              </a:rPr>
+              <a:t>denominator</a:t>
+            </a:r>
+            <a:r>
+              <a:rPr lang="de-AT" sz="1800" dirty="0">
+                <a:solidFill>
+                  <a:srgbClr val="000000"/>
+                </a:solidFill>
+                <a:latin typeface="Consolas" panose="020B0609020204030204" pitchFamily="49" charset="0"/>
+              </a:rPr>
+              <a:t> = </a:t>
+            </a:r>
+            <a:r>
+              <a:rPr lang="de-AT" sz="1800" dirty="0" err="1">
+                <a:solidFill>
+                  <a:srgbClr val="000000"/>
+                </a:solidFill>
+                <a:latin typeface="Consolas" panose="020B0609020204030204" pitchFamily="49" charset="0"/>
+              </a:rPr>
+              <a:t>Convert.ToDouble</a:t>
+            </a:r>
+            <a:r>
+              <a:rPr lang="de-AT" sz="1800" dirty="0">
+                <a:solidFill>
+                  <a:srgbClr val="000000"/>
+                </a:solidFill>
+                <a:latin typeface="Consolas" panose="020B0609020204030204" pitchFamily="49" charset="0"/>
+              </a:rPr>
+              <a:t>(</a:t>
+            </a:r>
+            <a:r>
+              <a:rPr lang="de-AT" sz="1800" dirty="0" err="1">
+                <a:solidFill>
+                  <a:srgbClr val="000000"/>
+                </a:solidFill>
+                <a:latin typeface="Consolas" panose="020B0609020204030204" pitchFamily="49" charset="0"/>
+              </a:rPr>
+              <a:t>userInput</a:t>
+            </a:r>
+            <a:r>
+              <a:rPr lang="de-AT" sz="1800" dirty="0">
+                <a:solidFill>
+                  <a:srgbClr val="000000"/>
+                </a:solidFill>
+                <a:latin typeface="Consolas" panose="020B0609020204030204" pitchFamily="49" charset="0"/>
+              </a:rPr>
+              <a:t>);</a:t>
+            </a:r>
+          </a:p>
+          <a:p>
+            <a:pPr marL="0" indent="0">
+              <a:buNone/>
+            </a:pPr>
+            <a:endParaRPr lang="de-AT" sz="1800" dirty="0">
+              <a:solidFill>
+                <a:srgbClr val="000000"/>
+              </a:solidFill>
+              <a:latin typeface="Consolas" panose="020B0609020204030204" pitchFamily="49" charset="0"/>
+            </a:endParaRPr>
+          </a:p>
+          <a:p>
+            <a:pPr marL="0" indent="0">
+              <a:buNone/>
+            </a:pPr>
+            <a:r>
+              <a:rPr lang="de-AT" sz="1800" dirty="0">
+                <a:solidFill>
+                  <a:srgbClr val="0000FF"/>
+                </a:solidFill>
+                <a:latin typeface="Consolas" panose="020B0609020204030204" pitchFamily="49" charset="0"/>
+              </a:rPr>
+              <a:t>double</a:t>
+            </a:r>
+            <a:r>
+              <a:rPr lang="de-AT" sz="1800" dirty="0">
+                <a:solidFill>
+                  <a:srgbClr val="000000"/>
+                </a:solidFill>
+                <a:latin typeface="Consolas" panose="020B0609020204030204" pitchFamily="49" charset="0"/>
+              </a:rPr>
+              <a:t> </a:t>
+            </a:r>
+            <a:r>
+              <a:rPr lang="de-AT" sz="1800" dirty="0" err="1">
+                <a:solidFill>
+                  <a:srgbClr val="000000"/>
+                </a:solidFill>
+                <a:latin typeface="Consolas" panose="020B0609020204030204" pitchFamily="49" charset="0"/>
+              </a:rPr>
+              <a:t>decimalValue</a:t>
+            </a:r>
+            <a:r>
+              <a:rPr lang="de-AT" sz="1800" dirty="0">
+                <a:solidFill>
+                  <a:srgbClr val="000000"/>
+                </a:solidFill>
+                <a:latin typeface="Consolas" panose="020B0609020204030204" pitchFamily="49" charset="0"/>
+              </a:rPr>
+              <a:t> = </a:t>
+            </a:r>
+            <a:r>
+              <a:rPr lang="de-AT" sz="1800" dirty="0" err="1">
+                <a:solidFill>
+                  <a:srgbClr val="000000"/>
+                </a:solidFill>
+                <a:latin typeface="Consolas" panose="020B0609020204030204" pitchFamily="49" charset="0"/>
+              </a:rPr>
+              <a:t>numerator</a:t>
+            </a:r>
+            <a:r>
+              <a:rPr lang="de-AT" sz="1800" dirty="0">
+                <a:solidFill>
+                  <a:srgbClr val="000000"/>
+                </a:solidFill>
+                <a:latin typeface="Consolas" panose="020B0609020204030204" pitchFamily="49" charset="0"/>
+              </a:rPr>
+              <a:t> / </a:t>
+            </a:r>
+            <a:r>
+              <a:rPr lang="de-AT" sz="1800" dirty="0" err="1">
+                <a:solidFill>
+                  <a:srgbClr val="000000"/>
+                </a:solidFill>
+                <a:latin typeface="Consolas" panose="020B0609020204030204" pitchFamily="49" charset="0"/>
+              </a:rPr>
+              <a:t>denominator</a:t>
+            </a:r>
+            <a:r>
+              <a:rPr lang="de-AT" sz="1800" dirty="0">
+                <a:solidFill>
+                  <a:srgbClr val="000000"/>
+                </a:solidFill>
+                <a:latin typeface="Consolas" panose="020B0609020204030204" pitchFamily="49" charset="0"/>
+              </a:rPr>
+              <a:t>;</a:t>
+            </a:r>
+          </a:p>
+          <a:p>
+            <a:pPr marL="0" indent="0">
+              <a:buNone/>
+            </a:pPr>
+            <a:endParaRPr lang="de-AT" sz="1800" dirty="0">
+              <a:solidFill>
+                <a:srgbClr val="000000"/>
+              </a:solidFill>
+              <a:latin typeface="Consolas" panose="020B0609020204030204" pitchFamily="49" charset="0"/>
+            </a:endParaRPr>
+          </a:p>
+          <a:p>
+            <a:pPr marL="0" indent="0">
+              <a:buNone/>
+            </a:pPr>
+            <a:r>
+              <a:rPr lang="de-AT" sz="1800" dirty="0" err="1">
+                <a:solidFill>
+                  <a:srgbClr val="000000"/>
+                </a:solidFill>
+                <a:latin typeface="Consolas" panose="020B0609020204030204" pitchFamily="49" charset="0"/>
+              </a:rPr>
+              <a:t>Console.WriteLine</a:t>
+            </a:r>
+            <a:r>
+              <a:rPr lang="de-AT" sz="1800" dirty="0">
+                <a:solidFill>
+                  <a:srgbClr val="000000"/>
+                </a:solidFill>
+                <a:latin typeface="Consolas" panose="020B0609020204030204" pitchFamily="49" charset="0"/>
+              </a:rPr>
+              <a:t>(</a:t>
+            </a:r>
+            <a:r>
+              <a:rPr lang="de-AT" sz="1800" dirty="0">
+                <a:solidFill>
+                  <a:srgbClr val="A31515"/>
+                </a:solidFill>
+                <a:latin typeface="Consolas" panose="020B0609020204030204" pitchFamily="49" charset="0"/>
+              </a:rPr>
+              <a:t>$"</a:t>
+            </a:r>
+            <a:r>
+              <a:rPr lang="de-AT" sz="1800" dirty="0">
+                <a:solidFill>
+                  <a:srgbClr val="000000"/>
+                </a:solidFill>
+                <a:latin typeface="Consolas" panose="020B0609020204030204" pitchFamily="49" charset="0"/>
+              </a:rPr>
+              <a:t>{</a:t>
+            </a:r>
+            <a:r>
+              <a:rPr lang="de-AT" sz="1800" dirty="0" err="1">
+                <a:solidFill>
+                  <a:srgbClr val="000000"/>
+                </a:solidFill>
+                <a:latin typeface="Consolas" panose="020B0609020204030204" pitchFamily="49" charset="0"/>
+              </a:rPr>
+              <a:t>numerator</a:t>
+            </a:r>
+            <a:r>
+              <a:rPr lang="de-AT" sz="1800" dirty="0">
+                <a:solidFill>
+                  <a:srgbClr val="000000"/>
+                </a:solidFill>
+                <a:latin typeface="Consolas" panose="020B0609020204030204" pitchFamily="49" charset="0"/>
+              </a:rPr>
+              <a:t>}</a:t>
+            </a:r>
+            <a:r>
+              <a:rPr lang="de-AT" sz="1800" dirty="0">
+                <a:solidFill>
+                  <a:srgbClr val="A31515"/>
+                </a:solidFill>
+                <a:latin typeface="Consolas" panose="020B0609020204030204" pitchFamily="49" charset="0"/>
+              </a:rPr>
+              <a:t>/</a:t>
+            </a:r>
+            <a:r>
+              <a:rPr lang="de-AT" sz="1800" dirty="0">
+                <a:solidFill>
+                  <a:srgbClr val="000000"/>
+                </a:solidFill>
+                <a:latin typeface="Consolas" panose="020B0609020204030204" pitchFamily="49" charset="0"/>
+              </a:rPr>
+              <a:t>{</a:t>
+            </a:r>
+            <a:r>
+              <a:rPr lang="de-AT" sz="1800" dirty="0" err="1">
+                <a:solidFill>
+                  <a:srgbClr val="000000"/>
+                </a:solidFill>
+                <a:latin typeface="Consolas" panose="020B0609020204030204" pitchFamily="49" charset="0"/>
+              </a:rPr>
+              <a:t>denominator</a:t>
+            </a:r>
+            <a:r>
+              <a:rPr lang="de-AT" sz="1800" dirty="0">
+                <a:solidFill>
+                  <a:srgbClr val="000000"/>
+                </a:solidFill>
+                <a:latin typeface="Consolas" panose="020B0609020204030204" pitchFamily="49" charset="0"/>
+              </a:rPr>
+              <a:t>}</a:t>
+            </a:r>
+            <a:r>
+              <a:rPr lang="de-AT" sz="1800" dirty="0">
+                <a:solidFill>
+                  <a:srgbClr val="A31515"/>
+                </a:solidFill>
+                <a:latin typeface="Consolas" panose="020B0609020204030204" pitchFamily="49" charset="0"/>
+              </a:rPr>
+              <a:t>=</a:t>
+            </a:r>
+            <a:r>
+              <a:rPr lang="de-AT" sz="1800" dirty="0">
+                <a:solidFill>
+                  <a:srgbClr val="000000"/>
+                </a:solidFill>
+                <a:latin typeface="Consolas" panose="020B0609020204030204" pitchFamily="49" charset="0"/>
+              </a:rPr>
+              <a:t>{</a:t>
+            </a:r>
+            <a:r>
+              <a:rPr lang="de-AT" sz="1800" dirty="0" err="1">
+                <a:solidFill>
+                  <a:srgbClr val="000000"/>
+                </a:solidFill>
+                <a:latin typeface="Consolas" panose="020B0609020204030204" pitchFamily="49" charset="0"/>
+              </a:rPr>
+              <a:t>decimalValue</a:t>
+            </a:r>
+            <a:r>
+              <a:rPr lang="de-AT" sz="1800" dirty="0">
+                <a:solidFill>
+                  <a:srgbClr val="000000"/>
+                </a:solidFill>
+                <a:latin typeface="Consolas" panose="020B0609020204030204" pitchFamily="49" charset="0"/>
+              </a:rPr>
+              <a:t>}</a:t>
+            </a:r>
+            <a:r>
+              <a:rPr lang="de-AT" sz="1800" dirty="0">
+                <a:solidFill>
+                  <a:srgbClr val="A31515"/>
+                </a:solidFill>
+                <a:latin typeface="Consolas" panose="020B0609020204030204" pitchFamily="49" charset="0"/>
+              </a:rPr>
+              <a:t>"</a:t>
+            </a:r>
+            <a:r>
+              <a:rPr lang="de-AT" sz="1800" dirty="0">
+                <a:solidFill>
+                  <a:srgbClr val="000000"/>
+                </a:solidFill>
+                <a:latin typeface="Consolas" panose="020B0609020204030204" pitchFamily="49" charset="0"/>
+              </a:rPr>
+              <a:t>);</a:t>
+            </a:r>
+          </a:p>
+          <a:p>
+            <a:endParaRPr lang="de-AT" dirty="0"/>
           </a:p>
         </p:txBody>
       </p:sp>
-      <p:pic>
-        <p:nvPicPr>
-          <p:cNvPr id="6" name="Grafik 5">
-            <a:extLst>
-              <a:ext uri="{FF2B5EF4-FFF2-40B4-BE49-F238E27FC236}">
-                <a16:creationId xmlns:a16="http://schemas.microsoft.com/office/drawing/2014/main" xmlns="" id="{485E2D92-955F-4A2C-AD44-F732890D609D}"/>
-              </a:ext>
-            </a:extLst>
-          </p:cNvPr>
-          <p:cNvPicPr>
-            <a:picLocks noChangeAspect="1"/>
-          </p:cNvPicPr>
-          <p:nvPr/>
-        </p:nvPicPr>
-        <p:blipFill>
-          <a:blip r:embed="rId2"/>
-          <a:stretch>
-            <a:fillRect/>
-          </a:stretch>
-        </p:blipFill>
-        <p:spPr>
-          <a:xfrm>
-            <a:off x="885825" y="1076325"/>
-            <a:ext cx="7372350" cy="4705350"/>
-          </a:xfrm>
-          <a:prstGeom prst="rect">
-            <a:avLst/>
-          </a:prstGeom>
-        </p:spPr>
-      </p:pic>
     </p:spTree>
     <p:extLst>
       <p:ext uri="{BB962C8B-B14F-4D97-AF65-F5344CB8AC3E}">
@@ -9451,13 +10026,8 @@
           <a:p>
             <a:r>
               <a:rPr lang="de-AT" dirty="0"/>
-              <a:t>Ausgabe von Variablen mit </a:t>
-            </a:r>
-            <a:r>
-              <a:rPr lang="de-AT" dirty="0" smtClean="0"/>
-              <a:t>Platzhaltern</a:t>
-            </a:r>
-            <a:endParaRPr lang="de-AT" dirty="0"/>
+              <a:t>Ausgabe von Variablen mit Platzhaltern</a:t>
+            </a:r>
           </a:p>
         </p:txBody>
       </p:sp>
@@ -9476,17 +10046,22 @@
           <a:bodyPr/>
           <a:lstStyle/>
           <a:p>
-            <a:pPr>
+            <a:pPr marL="0" indent="0">
               <a:spcBef>
                 <a:spcPct val="40000"/>
               </a:spcBef>
+              <a:buNone/>
             </a:pPr>
             <a:r>
-              <a:rPr lang="en-US" altLang="de-DE" sz="2000" dirty="0" err="1"/>
+              <a:rPr lang="en-US" altLang="de-DE" sz="2000" dirty="0" err="1">
+                <a:latin typeface="Consolas" panose="020B0609020204030204" pitchFamily="49" charset="0"/>
+              </a:rPr>
               <a:t>Console.Write</a:t>
             </a:r>
             <a:r>
-              <a:rPr lang="en-US" altLang="de-DE" sz="2000" dirty="0"/>
+              <a:rPr lang="en-US" altLang="de-DE" sz="2000" dirty="0">
+                <a:latin typeface="Consolas" panose="020B0609020204030204" pitchFamily="49" charset="0"/>
+              </a:rPr>
               <a:t>(</a:t>
             </a:r>
             <a:r>
@@ -9494,11 +10069,14 @@
                 <a:solidFill>
                   <a:srgbClr val="FF0000"/>
                 </a:solidFill>
+                <a:latin typeface="Consolas" panose="020B0609020204030204" pitchFamily="49" charset="0"/>
               </a:rPr>
               <a:t>$</a:t>
             </a:r>
             <a:r>
-              <a:rPr lang="en-US" altLang="de-DE" sz="2000" dirty="0"/>
+              <a:rPr lang="en-US" altLang="de-DE" sz="2000" dirty="0">
+                <a:latin typeface="Consolas" panose="020B0609020204030204" pitchFamily="49" charset="0"/>
+              </a:rPr>
               <a:t>"Hello </a:t>
             </a:r>
             <a:r>
@@ -9506,37 +10084,32 @@
                 <a:solidFill>
                   <a:srgbClr val="FF0000"/>
                 </a:solidFill>
+                <a:latin typeface="Consolas" panose="020B0609020204030204" pitchFamily="49" charset="0"/>
               </a:rPr>
               <a:t>{name}</a:t>
             </a:r>
             <a:r>
-              <a:rPr lang="en-US" altLang="de-DE" sz="2000" dirty="0"/>
-              <a:t>");	// </a:t>
-            </a:r>
-            <a:r>
-              <a:rPr lang="en-US" altLang="de-DE" sz="2000" dirty="0" err="1"/>
-              <a:t>Platzhalter</a:t>
-            </a:r>
-            <a:r>
-              <a:rPr lang="en-US" altLang="de-DE" sz="2000" dirty="0"/>
-              <a:t> </a:t>
-            </a:r>
-            <a:r>
-              <a:rPr lang="en-US" altLang="de-DE" sz="2000" dirty="0" err="1"/>
-              <a:t>für</a:t>
-            </a:r>
-            <a:r>
-              <a:rPr lang="en-US" altLang="de-DE" sz="2000" dirty="0"/>
-              <a:t> Variable</a:t>
-            </a:r>
-          </a:p>
-          <a:p>
-            <a:r>
-              <a:rPr lang="en-US" altLang="de-DE" sz="2000" dirty="0" err="1"/>
+              <a:rPr lang="en-US" altLang="de-DE" sz="2000" dirty="0">
+                <a:latin typeface="Consolas" panose="020B0609020204030204" pitchFamily="49" charset="0"/>
+              </a:rPr>
+              <a:t>");</a:t>
+            </a:r>
+            <a:endParaRPr lang="en-US" altLang="de-DE" sz="2000" dirty="0"/>
+          </a:p>
+          <a:p>
+            <a:pPr marL="0" indent="0">
+              <a:buNone/>
+            </a:pPr>
+            <a:r>
+              <a:rPr lang="en-US" altLang="de-DE" sz="2000" dirty="0" err="1">
+                <a:latin typeface="Consolas" panose="020B0609020204030204" pitchFamily="49" charset="0"/>
+              </a:rPr>
               <a:t>Console.WriteLine</a:t>
             </a:r>
             <a:r>
-              <a:rPr lang="en-US" altLang="de-DE" sz="2000" dirty="0"/>
+              <a:rPr lang="en-US" altLang="de-DE" sz="2000" dirty="0">
+                <a:latin typeface="Consolas" panose="020B0609020204030204" pitchFamily="49" charset="0"/>
+              </a:rPr>
               <a:t>(</a:t>
             </a:r>
             <a:r>
@@ -9544,11 +10117,14 @@
                 <a:solidFill>
                   <a:srgbClr val="FF0000"/>
                 </a:solidFill>
+                <a:latin typeface="Consolas" panose="020B0609020204030204" pitchFamily="49" charset="0"/>
               </a:rPr>
               <a:t>$</a:t>
             </a:r>
             <a:r>
-              <a:rPr lang="en-US" altLang="de-DE" sz="2000" dirty="0"/>
+              <a:rPr lang="en-US" altLang="de-DE" sz="2000" dirty="0">
+                <a:latin typeface="Consolas" panose="020B0609020204030204" pitchFamily="49" charset="0"/>
+              </a:rPr>
               <a:t>"</a:t>
             </a:r>
             <a:r>
@@ -9556,11 +10132,14 @@
                 <a:solidFill>
                   <a:srgbClr val="FF0000"/>
                 </a:solidFill>
+                <a:latin typeface="Consolas" panose="020B0609020204030204" pitchFamily="49" charset="0"/>
               </a:rPr>
               <a:t>{x}</a:t>
             </a:r>
             <a:r>
-              <a:rPr lang="en-US" altLang="de-DE" sz="2000" dirty="0"/>
+              <a:rPr lang="en-US" altLang="de-DE" sz="2000" dirty="0">
+                <a:latin typeface="Consolas" panose="020B0609020204030204" pitchFamily="49" charset="0"/>
+              </a:rPr>
               <a:t> = </a:t>
             </a:r>
             <a:r>
@@ -9568,14 +10147,19 @@
                 <a:solidFill>
                   <a:srgbClr val="FF0000"/>
                 </a:solidFill>
+                <a:latin typeface="Consolas" panose="020B0609020204030204" pitchFamily="49" charset="0"/>
               </a:rPr>
               <a:t>{y}</a:t>
             </a:r>
             <a:r>
-              <a:rPr lang="en-US" altLang="de-DE" sz="2000" dirty="0"/>
+              <a:rPr lang="en-US" altLang="de-DE" sz="2000" dirty="0">
+                <a:latin typeface="Consolas" panose="020B0609020204030204" pitchFamily="49" charset="0"/>
+              </a:rPr>
               <a:t>");</a:t>
             </a:r>
-            <a:endParaRPr lang="de-AT" altLang="de-DE" sz="2000" dirty="0"/>
+            <a:endParaRPr lang="de-AT" altLang="de-DE" sz="2000" dirty="0">
+              <a:latin typeface="Consolas" panose="020B0609020204030204" pitchFamily="49" charset="0"/>
+            </a:endParaRPr>
           </a:p>
           <a:p>
             <a:endParaRPr lang="de-AT" dirty="0"/>
@@ -10537,13 +11121,8 @@
           <a:p>
             <a:r>
               <a:rPr lang="de-AT" dirty="0"/>
-              <a:t>Ausgabe von Variablen mit </a:t>
-            </a:r>
-            <a:r>
-              <a:rPr lang="de-AT" dirty="0" smtClean="0"/>
-              <a:t>Platzhaltern 2</a:t>
-            </a:r>
-            <a:endParaRPr lang="de-AT" dirty="0"/>
+              <a:t>Ausgabe von Variablen mit Platzhaltern 2</a:t>
+            </a:r>
           </a:p>
         </p:txBody>
       </p:sp>
@@ -10562,17 +11141,22 @@
           <a:bodyPr/>
           <a:lstStyle/>
           <a:p>
-            <a:pPr>
+            <a:pPr marL="0" indent="0">
               <a:spcBef>
                 <a:spcPct val="40000"/>
               </a:spcBef>
+              <a:buNone/>
             </a:pPr>
             <a:r>
-              <a:rPr lang="en-US" altLang="de-DE" sz="2000" dirty="0" err="1"/>
+              <a:rPr lang="en-US" altLang="de-DE" sz="2000" dirty="0" err="1">
+                <a:latin typeface="Consolas" panose="020B0609020204030204" pitchFamily="49" charset="0"/>
+              </a:rPr>
               <a:t>Console.Write</a:t>
             </a:r>
             <a:r>
-              <a:rPr lang="en-US" altLang="de-DE" sz="2000" dirty="0"/>
+              <a:rPr lang="en-US" altLang="de-DE" sz="2000" dirty="0">
+                <a:latin typeface="Consolas" panose="020B0609020204030204" pitchFamily="49" charset="0"/>
+              </a:rPr>
               <a:t>("Hello </a:t>
             </a:r>
             <a:r>
@@ -10580,26 +11164,31 @@
                 <a:solidFill>
                   <a:srgbClr val="FF0000"/>
                 </a:solidFill>
+                <a:latin typeface="Consolas" panose="020B0609020204030204" pitchFamily="49" charset="0"/>
               </a:rPr>
               <a:t>{0}</a:t>
             </a:r>
             <a:r>
-              <a:rPr lang="en-US" altLang="de-DE" sz="2000" dirty="0"/>
-              <a:t>", name);	// </a:t>
-            </a:r>
-            <a:r>
-              <a:rPr lang="en-US" altLang="de-DE" sz="2000" dirty="0" err="1"/>
-              <a:t>Platzhalter</a:t>
-            </a:r>
-            <a:endParaRPr lang="en-US" altLang="de-DE" sz="2000" dirty="0"/>
-          </a:p>
-          <a:p>
-            <a:r>
-              <a:rPr lang="en-US" altLang="de-DE" sz="2000" dirty="0" err="1"/>
+              <a:rPr lang="en-US" altLang="de-DE" sz="2000" dirty="0">
+                <a:latin typeface="Consolas" panose="020B0609020204030204" pitchFamily="49" charset="0"/>
+              </a:rPr>
+              <a:t>", name);</a:t>
+            </a:r>
+          </a:p>
+          <a:p>
+            <a:pPr marL="0" indent="0">
+              <a:buNone/>
+            </a:pPr>
+            <a:r>
+              <a:rPr lang="en-US" altLang="de-DE" sz="2000" dirty="0" err="1">
+                <a:latin typeface="Consolas" panose="020B0609020204030204" pitchFamily="49" charset="0"/>
+              </a:rPr>
               <a:t>Console.WriteLine</a:t>
             </a:r>
             <a:r>
-              <a:rPr lang="en-US" altLang="de-DE" sz="2000" dirty="0"/>
+              <a:rPr lang="en-US" altLang="de-DE" sz="2000" dirty="0">
+                <a:latin typeface="Consolas" panose="020B0609020204030204" pitchFamily="49" charset="0"/>
+              </a:rPr>
               <a:t>("</a:t>
             </a:r>
             <a:r>
@@ -10607,11 +11196,14 @@
                 <a:solidFill>
                   <a:srgbClr val="FF0000"/>
                 </a:solidFill>
+                <a:latin typeface="Consolas" panose="020B0609020204030204" pitchFamily="49" charset="0"/>
               </a:rPr>
               <a:t>{0}</a:t>
             </a:r>
             <a:r>
-              <a:rPr lang="en-US" altLang="de-DE" sz="2000" dirty="0"/>
+              <a:rPr lang="en-US" altLang="de-DE" sz="2000" dirty="0">
+                <a:latin typeface="Consolas" panose="020B0609020204030204" pitchFamily="49" charset="0"/>
+              </a:rPr>
               <a:t> = </a:t>
             </a:r>
             <a:r>
@@ -10619,14 +11211,19 @@
                 <a:solidFill>
                   <a:srgbClr val="FF0000"/>
                 </a:solidFill>
+                <a:latin typeface="Consolas" panose="020B0609020204030204" pitchFamily="49" charset="0"/>
               </a:rPr>
               <a:t>{1}</a:t>
             </a:r>
             <a:r>
-              <a:rPr lang="en-US" altLang="de-DE" sz="2000" dirty="0"/>
+              <a:rPr lang="en-US" altLang="de-DE" sz="2000" dirty="0">
+                <a:latin typeface="Consolas" panose="020B0609020204030204" pitchFamily="49" charset="0"/>
+              </a:rPr>
               <a:t>", x, y);</a:t>
             </a:r>
-            <a:endParaRPr lang="de-AT" altLang="de-DE" sz="2000" dirty="0"/>
+            <a:endParaRPr lang="de-AT" altLang="de-DE" sz="2000" dirty="0">
+              <a:latin typeface="Consolas" panose="020B0609020204030204" pitchFamily="49" charset="0"/>
+            </a:endParaRPr>
           </a:p>
           <a:p>
             <a:endParaRPr lang="de-AT" dirty="0"/>
@@ -12276,8 +12873,8 @@
         </p:nvSpPr>
         <p:spPr>
           <a:xfrm>
-            <a:off x="685800" y="1434480"/>
-            <a:ext cx="7772400" cy="914400"/>
+            <a:off x="685800" y="1255160"/>
+            <a:ext cx="7772400" cy="4910144"/>
           </a:xfrm>
           <a:prstGeom prst="rect">
             <a:avLst/>
@@ -12463,11 +13060,15 @@
               </a:tabLst>
             </a:pPr>
             <a:r>
-              <a:rPr lang="en-US" altLang="de-DE" sz="1800" dirty="0" err="1"/>
+              <a:rPr lang="en-US" altLang="de-DE" sz="1800" dirty="0" err="1">
+                <a:latin typeface="Consolas" panose="020B0609020204030204" pitchFamily="49" charset="0"/>
+              </a:rPr>
               <a:t>int</a:t>
             </a:r>
             <a:r>
-              <a:rPr lang="en-US" altLang="de-DE" sz="1800" dirty="0"/>
+              <a:rPr lang="en-US" altLang="de-DE" sz="1800" dirty="0">
+                <a:latin typeface="Consolas" panose="020B0609020204030204" pitchFamily="49" charset="0"/>
+              </a:rPr>
               <a:t> x = 17;</a:t>
             </a:r>
           </a:p>
@@ -12482,7 +13083,9 @@
                 <a:tab pos="3657600" algn="l"/>
               </a:tabLst>
             </a:pPr>
-            <a:endParaRPr lang="en-US" altLang="de-DE" sz="1800" dirty="0"/>
+            <a:endParaRPr lang="en-US" altLang="de-DE" sz="1800" dirty="0">
+              <a:latin typeface="Consolas" panose="020B0609020204030204" pitchFamily="49" charset="0"/>
+            </a:endParaRPr>
           </a:p>
           <a:p>
             <a:pPr>
@@ -12496,11 +13099,15 @@
               </a:tabLst>
             </a:pPr>
             <a:r>
-              <a:rPr lang="en-US" altLang="de-DE" sz="1800" dirty="0" err="1"/>
+              <a:rPr lang="en-US" altLang="de-DE" sz="1800" dirty="0" err="1">
+                <a:latin typeface="Consolas" panose="020B0609020204030204" pitchFamily="49" charset="0"/>
+              </a:rPr>
               <a:t>Console.WriteLine</a:t>
             </a:r>
             <a:r>
-              <a:rPr lang="en-US" altLang="de-DE" sz="1800" dirty="0"/>
+              <a:rPr lang="en-US" altLang="de-DE" sz="1800" dirty="0">
+                <a:latin typeface="Consolas" panose="020B0609020204030204" pitchFamily="49" charset="0"/>
+              </a:rPr>
               <a:t>($</a:t>
             </a:r>
             <a:r>
@@ -12508,20 +13115,25 @@
                 <a:solidFill>
                   <a:srgbClr val="FF0000"/>
                 </a:solidFill>
+                <a:latin typeface="Consolas" panose="020B0609020204030204" pitchFamily="49" charset="0"/>
               </a:rPr>
               <a:t>"{x}"</a:t>
             </a:r>
             <a:r>
-              <a:rPr lang="en-US" altLang="de-DE" sz="1800" dirty="0"/>
-              <a:t>);	</a:t>
-            </a:r>
-            <a:r>
               <a:rPr lang="en-US" altLang="de-DE" sz="1800" dirty="0">
-                <a:latin typeface="Courier New" panose="02070309020205020404" pitchFamily="49" charset="0"/>
+                <a:latin typeface="Consolas" panose="020B0609020204030204" pitchFamily="49" charset="0"/>
+              </a:rPr>
+              <a:t>);	       </a:t>
+            </a:r>
+            <a:r>
+              <a:rPr lang="en-US" altLang="de-DE" sz="1800" dirty="0">
+                <a:solidFill>
+                  <a:srgbClr val="00B050"/>
+                </a:solidFill>
+                <a:latin typeface="Consolas" panose="020B0609020204030204" pitchFamily="49" charset="0"/>
               </a:rPr>
               <a:t>17</a:t>
             </a:r>
-            <a:endParaRPr lang="en-US" altLang="de-DE" sz="1800" dirty="0"/>
           </a:p>
           <a:p>
             <a:pPr>
@@ -12535,11 +13147,15 @@
               </a:tabLst>
             </a:pPr>
             <a:r>
-              <a:rPr lang="en-US" altLang="de-DE" sz="1800" dirty="0" err="1"/>
+              <a:rPr lang="en-US" altLang="de-DE" sz="1800" dirty="0" err="1">
+                <a:latin typeface="Consolas" panose="020B0609020204030204" pitchFamily="49" charset="0"/>
+              </a:rPr>
               <a:t>Console.WriteLine</a:t>
             </a:r>
             <a:r>
-              <a:rPr lang="en-US" altLang="de-DE" sz="1800" dirty="0"/>
+              <a:rPr lang="en-US" altLang="de-DE" sz="1800" dirty="0">
+                <a:latin typeface="Consolas" panose="020B0609020204030204" pitchFamily="49" charset="0"/>
+              </a:rPr>
               <a:t>($</a:t>
             </a:r>
             <a:r>
@@ -12547,11 +13163,14 @@
                 <a:solidFill>
                   <a:srgbClr val="FF0000"/>
                 </a:solidFill>
+                <a:latin typeface="Consolas" panose="020B0609020204030204" pitchFamily="49" charset="0"/>
               </a:rPr>
               <a:t>"{</a:t>
             </a:r>
             <a:r>
-              <a:rPr lang="en-US" altLang="de-DE" sz="1800" dirty="0"/>
+              <a:rPr lang="en-US" altLang="de-DE" sz="1800" dirty="0">
+                <a:latin typeface="Consolas" panose="020B0609020204030204" pitchFamily="49" charset="0"/>
+              </a:rPr>
               <a:t>x</a:t>
             </a:r>
             <a:r>
@@ -12559,20 +13178,599 @@
                 <a:solidFill>
                   <a:srgbClr val="FF0000"/>
                 </a:solidFill>
+                <a:latin typeface="Consolas" panose="020B0609020204030204" pitchFamily="49" charset="0"/>
               </a:rPr>
               <a:t>,5}"</a:t>
             </a:r>
             <a:r>
-              <a:rPr lang="en-US" altLang="de-DE" sz="1800" dirty="0"/>
-              <a:t>,);	</a:t>
-            </a:r>
-            <a:r>
               <a:rPr lang="en-US" altLang="de-DE" sz="1800" dirty="0">
-                <a:latin typeface="Courier New" panose="02070309020205020404" pitchFamily="49" charset="0"/>
-              </a:rPr>
-              <a:t>   17</a:t>
-            </a:r>
-            <a:endParaRPr lang="en-US" altLang="de-DE" sz="1800" dirty="0"/>
+                <a:latin typeface="Consolas" panose="020B0609020204030204" pitchFamily="49" charset="0"/>
+              </a:rPr>
+              <a:t>);	          </a:t>
+            </a:r>
+            <a:r>
+              <a:rPr lang="en-US" altLang="de-DE" sz="1800" dirty="0">
+                <a:solidFill>
+                  <a:srgbClr val="00B050"/>
+                </a:solidFill>
+                <a:latin typeface="Consolas" panose="020B0609020204030204" pitchFamily="49" charset="0"/>
+              </a:rPr>
+              <a:t>17</a:t>
+            </a:r>
+          </a:p>
+          <a:p>
+            <a:pPr>
+              <a:spcBef>
+                <a:spcPct val="0"/>
+              </a:spcBef>
+              <a:buFontTx/>
+              <a:buNone/>
+              <a:tabLst>
+                <a:tab pos="3657600" algn="l"/>
+              </a:tabLst>
+            </a:pPr>
+            <a:endParaRPr lang="en-US" altLang="de-DE" sz="1800" dirty="0">
+              <a:latin typeface="Consolas" panose="020B0609020204030204" pitchFamily="49" charset="0"/>
+            </a:endParaRPr>
+          </a:p>
+          <a:p>
+            <a:pPr marL="0" indent="0">
+              <a:buNone/>
+            </a:pPr>
+            <a:r>
+              <a:rPr lang="en-US" altLang="de-DE" sz="1800" dirty="0" err="1">
+                <a:latin typeface="Consolas" panose="020B0609020204030204" pitchFamily="49" charset="0"/>
+              </a:rPr>
+              <a:t>Console.WriteLine</a:t>
+            </a:r>
+            <a:r>
+              <a:rPr lang="en-US" altLang="de-DE" sz="1800" dirty="0">
+                <a:latin typeface="Consolas" panose="020B0609020204030204" pitchFamily="49" charset="0"/>
+              </a:rPr>
+              <a:t>($</a:t>
+            </a:r>
+            <a:r>
+              <a:rPr lang="en-US" altLang="de-DE" sz="1800" dirty="0">
+                <a:solidFill>
+                  <a:srgbClr val="FF0000"/>
+                </a:solidFill>
+                <a:latin typeface="Consolas" panose="020B0609020204030204" pitchFamily="49" charset="0"/>
+              </a:rPr>
+              <a:t>"{</a:t>
+            </a:r>
+            <a:r>
+              <a:rPr lang="en-US" altLang="de-DE" sz="1800" dirty="0" err="1">
+                <a:latin typeface="Consolas" panose="020B0609020204030204" pitchFamily="49" charset="0"/>
+              </a:rPr>
+              <a:t>x</a:t>
+            </a:r>
+            <a:r>
+              <a:rPr lang="en-US" altLang="de-DE" sz="1800" dirty="0" err="1">
+                <a:solidFill>
+                  <a:srgbClr val="FF0000"/>
+                </a:solidFill>
+                <a:latin typeface="Consolas" panose="020B0609020204030204" pitchFamily="49" charset="0"/>
+              </a:rPr>
+              <a:t>:d</a:t>
+            </a:r>
+            <a:r>
+              <a:rPr lang="en-US" altLang="de-DE" sz="1800" dirty="0">
+                <a:solidFill>
+                  <a:srgbClr val="FF0000"/>
+                </a:solidFill>
+                <a:latin typeface="Consolas" panose="020B0609020204030204" pitchFamily="49" charset="0"/>
+              </a:rPr>
+              <a:t>}"</a:t>
+            </a:r>
+            <a:r>
+              <a:rPr lang="en-US" altLang="de-DE" sz="1800" dirty="0">
+                <a:latin typeface="Consolas" panose="020B0609020204030204" pitchFamily="49" charset="0"/>
+              </a:rPr>
+              <a:t>);	       </a:t>
+            </a:r>
+            <a:r>
+              <a:rPr lang="en-US" altLang="de-DE" sz="1800" dirty="0">
+                <a:solidFill>
+                  <a:srgbClr val="00B050"/>
+                </a:solidFill>
+                <a:latin typeface="Consolas" panose="020B0609020204030204" pitchFamily="49" charset="0"/>
+              </a:rPr>
+              <a:t>17</a:t>
+            </a:r>
+          </a:p>
+          <a:p>
+            <a:pPr marL="0" indent="0">
+              <a:buNone/>
+            </a:pPr>
+            <a:r>
+              <a:rPr lang="en-US" altLang="de-DE" sz="1800" dirty="0" err="1">
+                <a:latin typeface="Consolas" panose="020B0609020204030204" pitchFamily="49" charset="0"/>
+              </a:rPr>
+              <a:t>Console.WriteLine</a:t>
+            </a:r>
+            <a:r>
+              <a:rPr lang="en-US" altLang="de-DE" sz="1800" dirty="0">
+                <a:latin typeface="Consolas" panose="020B0609020204030204" pitchFamily="49" charset="0"/>
+              </a:rPr>
+              <a:t>($</a:t>
+            </a:r>
+            <a:r>
+              <a:rPr lang="en-US" altLang="de-DE" sz="1800" dirty="0">
+                <a:solidFill>
+                  <a:srgbClr val="FF0000"/>
+                </a:solidFill>
+                <a:latin typeface="Consolas" panose="020B0609020204030204" pitchFamily="49" charset="0"/>
+              </a:rPr>
+              <a:t>"{</a:t>
+            </a:r>
+            <a:r>
+              <a:rPr lang="en-US" altLang="de-DE" sz="1800" dirty="0">
+                <a:latin typeface="Consolas" panose="020B0609020204030204" pitchFamily="49" charset="0"/>
+              </a:rPr>
+              <a:t>x</a:t>
+            </a:r>
+            <a:r>
+              <a:rPr lang="en-US" altLang="de-DE" sz="1800" dirty="0">
+                <a:solidFill>
+                  <a:srgbClr val="FF0000"/>
+                </a:solidFill>
+                <a:latin typeface="Consolas" panose="020B0609020204030204" pitchFamily="49" charset="0"/>
+              </a:rPr>
+              <a:t>,5:d3}"</a:t>
+            </a:r>
+            <a:r>
+              <a:rPr lang="en-US" altLang="de-DE" sz="1800" dirty="0">
+                <a:latin typeface="Consolas" panose="020B0609020204030204" pitchFamily="49" charset="0"/>
+              </a:rPr>
+              <a:t>);	  </a:t>
+            </a:r>
+            <a:r>
+              <a:rPr lang="en-US" altLang="de-DE" sz="1800" dirty="0">
+                <a:solidFill>
+                  <a:srgbClr val="00B050"/>
+                </a:solidFill>
+                <a:latin typeface="Consolas" panose="020B0609020204030204" pitchFamily="49" charset="0"/>
+              </a:rPr>
+              <a:t>017</a:t>
+            </a:r>
+          </a:p>
+          <a:p>
+            <a:pPr>
+              <a:spcBef>
+                <a:spcPct val="0"/>
+              </a:spcBef>
+              <a:buFontTx/>
+              <a:buNone/>
+              <a:tabLst>
+                <a:tab pos="3657600" algn="l"/>
+              </a:tabLst>
+            </a:pPr>
+            <a:endParaRPr lang="en-US" altLang="de-DE" sz="1800" dirty="0">
+              <a:latin typeface="Consolas" panose="020B0609020204030204" pitchFamily="49" charset="0"/>
+            </a:endParaRPr>
+          </a:p>
+          <a:p>
+            <a:pPr marL="0" indent="0">
+              <a:buNone/>
+            </a:pPr>
+            <a:r>
+              <a:rPr lang="en-US" altLang="de-DE" sz="1800" dirty="0" err="1">
+                <a:latin typeface="Consolas" panose="020B0609020204030204" pitchFamily="49" charset="0"/>
+              </a:rPr>
+              <a:t>Console.WriteLine</a:t>
+            </a:r>
+            <a:r>
+              <a:rPr lang="en-US" altLang="de-DE" sz="1800" dirty="0">
+                <a:latin typeface="Consolas" panose="020B0609020204030204" pitchFamily="49" charset="0"/>
+              </a:rPr>
+              <a:t>($</a:t>
+            </a:r>
+            <a:r>
+              <a:rPr lang="en-US" altLang="de-DE" sz="1800" dirty="0">
+                <a:solidFill>
+                  <a:srgbClr val="FF0000"/>
+                </a:solidFill>
+                <a:latin typeface="Consolas" panose="020B0609020204030204" pitchFamily="49" charset="0"/>
+              </a:rPr>
+              <a:t>"{</a:t>
+            </a:r>
+            <a:r>
+              <a:rPr lang="en-US" altLang="de-DE" sz="1800" dirty="0" err="1">
+                <a:latin typeface="Consolas" panose="020B0609020204030204" pitchFamily="49" charset="0"/>
+              </a:rPr>
+              <a:t>x</a:t>
+            </a:r>
+            <a:r>
+              <a:rPr lang="en-US" altLang="de-DE" sz="1800" dirty="0" err="1">
+                <a:solidFill>
+                  <a:srgbClr val="FF0000"/>
+                </a:solidFill>
+                <a:latin typeface="Consolas" panose="020B0609020204030204" pitchFamily="49" charset="0"/>
+              </a:rPr>
+              <a:t>:f</a:t>
+            </a:r>
+            <a:r>
+              <a:rPr lang="en-US" altLang="de-DE" sz="1800" dirty="0">
+                <a:solidFill>
+                  <a:srgbClr val="FF0000"/>
+                </a:solidFill>
+                <a:latin typeface="Consolas" panose="020B0609020204030204" pitchFamily="49" charset="0"/>
+              </a:rPr>
+              <a:t>}"</a:t>
+            </a:r>
+            <a:r>
+              <a:rPr lang="en-US" altLang="de-DE" sz="1800" dirty="0">
+                <a:latin typeface="Consolas" panose="020B0609020204030204" pitchFamily="49" charset="0"/>
+              </a:rPr>
+              <a:t>);	       </a:t>
+            </a:r>
+            <a:r>
+              <a:rPr lang="en-US" altLang="de-DE" sz="1800" dirty="0">
+                <a:solidFill>
+                  <a:srgbClr val="00B050"/>
+                </a:solidFill>
+                <a:latin typeface="Consolas" panose="020B0609020204030204" pitchFamily="49" charset="0"/>
+              </a:rPr>
+              <a:t>17.00</a:t>
+            </a:r>
+          </a:p>
+          <a:p>
+            <a:pPr marL="0" indent="0">
+              <a:buNone/>
+            </a:pPr>
+            <a:r>
+              <a:rPr lang="en-US" altLang="de-DE" sz="1800" dirty="0" err="1">
+                <a:latin typeface="Consolas" panose="020B0609020204030204" pitchFamily="49" charset="0"/>
+              </a:rPr>
+              <a:t>Console.WriteLine</a:t>
+            </a:r>
+            <a:r>
+              <a:rPr lang="en-US" altLang="de-DE" sz="1800" dirty="0">
+                <a:latin typeface="Consolas" panose="020B0609020204030204" pitchFamily="49" charset="0"/>
+              </a:rPr>
+              <a:t>($</a:t>
+            </a:r>
+            <a:r>
+              <a:rPr lang="en-US" altLang="de-DE" sz="1800" dirty="0">
+                <a:solidFill>
+                  <a:srgbClr val="FF0000"/>
+                </a:solidFill>
+                <a:latin typeface="Consolas" panose="020B0609020204030204" pitchFamily="49" charset="0"/>
+              </a:rPr>
+              <a:t>"{</a:t>
+            </a:r>
+            <a:r>
+              <a:rPr lang="en-US" altLang="de-DE" sz="1800" dirty="0">
+                <a:latin typeface="Consolas" panose="020B0609020204030204" pitchFamily="49" charset="0"/>
+              </a:rPr>
+              <a:t>x</a:t>
+            </a:r>
+            <a:r>
+              <a:rPr lang="en-US" altLang="de-DE" sz="1800" dirty="0">
+                <a:solidFill>
+                  <a:srgbClr val="FF0000"/>
+                </a:solidFill>
+                <a:latin typeface="Consolas" panose="020B0609020204030204" pitchFamily="49" charset="0"/>
+              </a:rPr>
+              <a:t>:f1}"</a:t>
+            </a:r>
+            <a:r>
+              <a:rPr lang="en-US" altLang="de-DE" sz="1800" dirty="0">
+                <a:latin typeface="Consolas" panose="020B0609020204030204" pitchFamily="49" charset="0"/>
+              </a:rPr>
+              <a:t>);   	</a:t>
+            </a:r>
+            <a:r>
+              <a:rPr lang="en-US" altLang="de-DE" sz="1800" dirty="0">
+                <a:solidFill>
+                  <a:srgbClr val="00B050"/>
+                </a:solidFill>
+                <a:latin typeface="Consolas" panose="020B0609020204030204" pitchFamily="49" charset="0"/>
+              </a:rPr>
+              <a:t>17.0</a:t>
+            </a:r>
+          </a:p>
+          <a:p>
+            <a:pPr>
+              <a:spcBef>
+                <a:spcPct val="0"/>
+              </a:spcBef>
+              <a:buFontTx/>
+              <a:buNone/>
+              <a:tabLst>
+                <a:tab pos="3657600" algn="l"/>
+              </a:tabLst>
+            </a:pPr>
+            <a:endParaRPr lang="en-US" altLang="de-DE" sz="1800" dirty="0">
+              <a:latin typeface="Consolas" panose="020B0609020204030204" pitchFamily="49" charset="0"/>
+            </a:endParaRPr>
+          </a:p>
+          <a:p>
+            <a:pPr marL="0" indent="0">
+              <a:buNone/>
+            </a:pPr>
+            <a:r>
+              <a:rPr lang="en-US" altLang="de-DE" sz="1800" dirty="0" err="1">
+                <a:latin typeface="Consolas" panose="020B0609020204030204" pitchFamily="49" charset="0"/>
+              </a:rPr>
+              <a:t>Console.WriteLine</a:t>
+            </a:r>
+            <a:r>
+              <a:rPr lang="en-US" altLang="de-DE" sz="1800" dirty="0">
+                <a:latin typeface="Consolas" panose="020B0609020204030204" pitchFamily="49" charset="0"/>
+              </a:rPr>
+              <a:t>($</a:t>
+            </a:r>
+            <a:r>
+              <a:rPr lang="en-US" altLang="de-DE" sz="1800" dirty="0">
+                <a:solidFill>
+                  <a:srgbClr val="FF0000"/>
+                </a:solidFill>
+                <a:latin typeface="Consolas" panose="020B0609020204030204" pitchFamily="49" charset="0"/>
+              </a:rPr>
+              <a:t>"{</a:t>
+            </a:r>
+            <a:r>
+              <a:rPr lang="en-US" altLang="de-DE" sz="1800" dirty="0" err="1">
+                <a:latin typeface="Consolas" panose="020B0609020204030204" pitchFamily="49" charset="0"/>
+              </a:rPr>
+              <a:t>x</a:t>
+            </a:r>
+            <a:r>
+              <a:rPr lang="en-US" altLang="de-DE" sz="1800" dirty="0" err="1">
+                <a:solidFill>
+                  <a:srgbClr val="FF0000"/>
+                </a:solidFill>
+                <a:latin typeface="Consolas" panose="020B0609020204030204" pitchFamily="49" charset="0"/>
+              </a:rPr>
+              <a:t>:E</a:t>
+            </a:r>
+            <a:r>
+              <a:rPr lang="en-US" altLang="de-DE" sz="1800" dirty="0">
+                <a:solidFill>
+                  <a:srgbClr val="FF0000"/>
+                </a:solidFill>
+                <a:latin typeface="Consolas" panose="020B0609020204030204" pitchFamily="49" charset="0"/>
+              </a:rPr>
+              <a:t>}"</a:t>
+            </a:r>
+            <a:r>
+              <a:rPr lang="en-US" altLang="de-DE" sz="1800" dirty="0">
+                <a:latin typeface="Consolas" panose="020B0609020204030204" pitchFamily="49" charset="0"/>
+              </a:rPr>
+              <a:t>);	       </a:t>
+            </a:r>
+            <a:r>
+              <a:rPr lang="en-US" altLang="de-DE" sz="1800" dirty="0">
+                <a:solidFill>
+                  <a:srgbClr val="00B050"/>
+                </a:solidFill>
+                <a:latin typeface="Consolas" panose="020B0609020204030204" pitchFamily="49" charset="0"/>
+              </a:rPr>
+              <a:t>1.700000E+001</a:t>
+            </a:r>
+          </a:p>
+          <a:p>
+            <a:pPr marL="0" indent="0">
+              <a:buNone/>
+            </a:pPr>
+            <a:r>
+              <a:rPr lang="en-US" altLang="de-DE" sz="1800" dirty="0" err="1">
+                <a:latin typeface="Consolas" panose="020B0609020204030204" pitchFamily="49" charset="0"/>
+              </a:rPr>
+              <a:t>Console.WriteLine</a:t>
+            </a:r>
+            <a:r>
+              <a:rPr lang="en-US" altLang="de-DE" sz="1800" dirty="0">
+                <a:latin typeface="Consolas" panose="020B0609020204030204" pitchFamily="49" charset="0"/>
+              </a:rPr>
+              <a:t>($</a:t>
+            </a:r>
+            <a:r>
+              <a:rPr lang="en-US" altLang="de-DE" sz="1800" dirty="0">
+                <a:solidFill>
+                  <a:srgbClr val="FF0000"/>
+                </a:solidFill>
+                <a:latin typeface="Consolas" panose="020B0609020204030204" pitchFamily="49" charset="0"/>
+              </a:rPr>
+              <a:t>"{</a:t>
+            </a:r>
+            <a:r>
+              <a:rPr lang="en-US" altLang="de-DE" sz="1800" dirty="0">
+                <a:latin typeface="Consolas" panose="020B0609020204030204" pitchFamily="49" charset="0"/>
+              </a:rPr>
+              <a:t>x</a:t>
+            </a:r>
+            <a:r>
+              <a:rPr lang="en-US" altLang="de-DE" sz="1800" dirty="0">
+                <a:solidFill>
+                  <a:srgbClr val="FF0000"/>
+                </a:solidFill>
+                <a:latin typeface="Consolas" panose="020B0609020204030204" pitchFamily="49" charset="0"/>
+              </a:rPr>
+              <a:t>:e1}"</a:t>
+            </a:r>
+            <a:r>
+              <a:rPr lang="en-US" altLang="de-DE" sz="1800" dirty="0">
+                <a:latin typeface="Consolas" panose="020B0609020204030204" pitchFamily="49" charset="0"/>
+              </a:rPr>
+              <a:t>);	       </a:t>
+            </a:r>
+            <a:r>
+              <a:rPr lang="en-US" altLang="de-DE" sz="1800" dirty="0">
+                <a:solidFill>
+                  <a:srgbClr val="00B050"/>
+                </a:solidFill>
+                <a:latin typeface="Consolas" panose="020B0609020204030204" pitchFamily="49" charset="0"/>
+              </a:rPr>
+              <a:t>1.7e+001</a:t>
+            </a:r>
+          </a:p>
+          <a:p>
+            <a:pPr>
+              <a:spcBef>
+                <a:spcPct val="0"/>
+              </a:spcBef>
+              <a:buFontTx/>
+              <a:buNone/>
+              <a:tabLst>
+                <a:tab pos="3657600" algn="l"/>
+              </a:tabLst>
+            </a:pPr>
+            <a:endParaRPr lang="en-US" altLang="de-DE" sz="1800" dirty="0">
+              <a:latin typeface="Consolas" panose="020B0609020204030204" pitchFamily="49" charset="0"/>
+            </a:endParaRPr>
+          </a:p>
+          <a:p>
+            <a:pPr marL="0" indent="0">
+              <a:buNone/>
+            </a:pPr>
+            <a:r>
+              <a:rPr lang="en-US" altLang="de-DE" sz="1800" dirty="0" err="1">
+                <a:latin typeface="Consolas" panose="020B0609020204030204" pitchFamily="49" charset="0"/>
+              </a:rPr>
+              <a:t>Console.WriteLine</a:t>
+            </a:r>
+            <a:r>
+              <a:rPr lang="en-US" altLang="de-DE" sz="1800" dirty="0">
+                <a:latin typeface="Consolas" panose="020B0609020204030204" pitchFamily="49" charset="0"/>
+              </a:rPr>
+              <a:t>($</a:t>
+            </a:r>
+            <a:r>
+              <a:rPr lang="en-US" altLang="de-DE" sz="1800" dirty="0">
+                <a:solidFill>
+                  <a:srgbClr val="FF0000"/>
+                </a:solidFill>
+                <a:latin typeface="Consolas" panose="020B0609020204030204" pitchFamily="49" charset="0"/>
+              </a:rPr>
+              <a:t>"{</a:t>
+            </a:r>
+            <a:r>
+              <a:rPr lang="en-US" altLang="de-DE" sz="1800" dirty="0" err="1">
+                <a:latin typeface="Consolas" panose="020B0609020204030204" pitchFamily="49" charset="0"/>
+              </a:rPr>
+              <a:t>x</a:t>
+            </a:r>
+            <a:r>
+              <a:rPr lang="en-US" altLang="de-DE" sz="1800" dirty="0" err="1">
+                <a:solidFill>
+                  <a:srgbClr val="FF0000"/>
+                </a:solidFill>
+                <a:latin typeface="Consolas" panose="020B0609020204030204" pitchFamily="49" charset="0"/>
+              </a:rPr>
+              <a:t>:x</a:t>
+            </a:r>
+            <a:r>
+              <a:rPr lang="en-US" altLang="de-DE" sz="1800" dirty="0">
+                <a:solidFill>
+                  <a:srgbClr val="FF0000"/>
+                </a:solidFill>
+                <a:latin typeface="Consolas" panose="020B0609020204030204" pitchFamily="49" charset="0"/>
+              </a:rPr>
+              <a:t>}"</a:t>
+            </a:r>
+            <a:r>
+              <a:rPr lang="en-US" altLang="de-DE" sz="1800" dirty="0">
+                <a:latin typeface="Consolas" panose="020B0609020204030204" pitchFamily="49" charset="0"/>
+              </a:rPr>
+              <a:t>);	       </a:t>
+            </a:r>
+            <a:r>
+              <a:rPr lang="en-US" altLang="de-DE" sz="1800" dirty="0">
+                <a:solidFill>
+                  <a:srgbClr val="00B050"/>
+                </a:solidFill>
+                <a:latin typeface="Consolas" panose="020B0609020204030204" pitchFamily="49" charset="0"/>
+              </a:rPr>
+              <a:t>11</a:t>
+            </a:r>
+          </a:p>
+          <a:p>
+            <a:pPr marL="0" indent="0">
+              <a:buNone/>
+            </a:pPr>
+            <a:r>
+              <a:rPr lang="en-US" altLang="de-DE" sz="1800" dirty="0" err="1">
+                <a:latin typeface="Consolas" panose="020B0609020204030204" pitchFamily="49" charset="0"/>
+              </a:rPr>
+              <a:t>Console.WriteLine</a:t>
+            </a:r>
+            <a:r>
+              <a:rPr lang="en-US" altLang="de-DE" sz="1800" dirty="0">
+                <a:latin typeface="Consolas" panose="020B0609020204030204" pitchFamily="49" charset="0"/>
+              </a:rPr>
+              <a:t>($</a:t>
+            </a:r>
+            <a:r>
+              <a:rPr lang="en-US" altLang="de-DE" sz="1800" dirty="0">
+                <a:solidFill>
+                  <a:srgbClr val="FF0000"/>
+                </a:solidFill>
+                <a:latin typeface="Consolas" panose="020B0609020204030204" pitchFamily="49" charset="0"/>
+              </a:rPr>
+              <a:t>"{</a:t>
+            </a:r>
+            <a:r>
+              <a:rPr lang="en-US" altLang="de-DE" sz="1800" dirty="0">
+                <a:latin typeface="Consolas" panose="020B0609020204030204" pitchFamily="49" charset="0"/>
+              </a:rPr>
+              <a:t>x</a:t>
+            </a:r>
+            <a:r>
+              <a:rPr lang="en-US" altLang="de-DE" sz="1800" dirty="0">
+                <a:solidFill>
+                  <a:srgbClr val="FF0000"/>
+                </a:solidFill>
+                <a:latin typeface="Consolas" panose="020B0609020204030204" pitchFamily="49" charset="0"/>
+              </a:rPr>
+              <a:t>:</a:t>
+            </a:r>
+            <a:r>
+              <a:rPr lang="en-US" altLang="de-DE" sz="1800">
+                <a:solidFill>
+                  <a:srgbClr val="FF0000"/>
+                </a:solidFill>
+                <a:latin typeface="Consolas" panose="020B0609020204030204" pitchFamily="49" charset="0"/>
+              </a:rPr>
+              <a:t>x4}"</a:t>
+            </a:r>
+            <a:r>
+              <a:rPr lang="en-US" altLang="de-DE" sz="1800">
+                <a:latin typeface="Consolas" panose="020B0609020204030204" pitchFamily="49" charset="0"/>
+              </a:rPr>
+              <a:t>);       </a:t>
+            </a:r>
+            <a:r>
+              <a:rPr lang="en-US" altLang="de-DE" sz="1800">
+                <a:solidFill>
+                  <a:srgbClr val="00B050"/>
+                </a:solidFill>
+                <a:latin typeface="Consolas" panose="020B0609020204030204" pitchFamily="49" charset="0"/>
+              </a:rPr>
+              <a:t>0011</a:t>
+            </a:r>
+            <a:endParaRPr lang="en-US" altLang="de-DE" sz="1800" dirty="0">
+              <a:solidFill>
+                <a:srgbClr val="00B050"/>
+              </a:solidFill>
+              <a:latin typeface="Consolas" panose="020B0609020204030204" pitchFamily="49" charset="0"/>
+            </a:endParaRPr>
+          </a:p>
+          <a:p>
+            <a:pPr>
+              <a:spcBef>
+                <a:spcPct val="0"/>
+              </a:spcBef>
+              <a:buFontTx/>
+              <a:buNone/>
+              <a:tabLst>
+                <a:tab pos="3657600" algn="l"/>
+              </a:tabLst>
+            </a:pPr>
+            <a:endParaRPr lang="en-US" altLang="de-DE" sz="1800" dirty="0">
+              <a:latin typeface="Consolas" panose="020B0609020204030204" pitchFamily="49" charset="0"/>
+            </a:endParaRPr>
           </a:p>
         </p:txBody>
       </p:sp>
@@ -12744,124 +13942,9 @@
             </a:lvl9pPr>
           </a:lstStyle>
           <a:p>
-            <a:r>
-              <a:rPr lang="en-US" altLang="de-DE" sz="1800" dirty="0" err="1">
-                <a:latin typeface="Arial" panose="020B0604020202020204" pitchFamily="34" charset="0"/>
-              </a:rPr>
-              <a:t>Console.WriteLine</a:t>
-            </a:r>
-            <a:r>
-              <a:rPr lang="en-US" altLang="de-DE" sz="1800" dirty="0">
-                <a:latin typeface="Arial" panose="020B0604020202020204" pitchFamily="34" charset="0"/>
-              </a:rPr>
-              <a:t>(</a:t>
-            </a:r>
-            <a:r>
-              <a:rPr lang="en-US" altLang="de-DE" sz="1800" dirty="0"/>
-              <a:t>$</a:t>
-            </a:r>
-            <a:r>
-              <a:rPr lang="en-US" altLang="de-DE" sz="1800" dirty="0">
-                <a:solidFill>
-                  <a:srgbClr val="FF0000"/>
-                </a:solidFill>
-                <a:latin typeface="Arial" panose="020B0604020202020204" pitchFamily="34" charset="0"/>
-              </a:rPr>
-              <a:t>"{</a:t>
-            </a:r>
-            <a:r>
-              <a:rPr lang="en-US" altLang="de-DE" sz="1800" dirty="0" err="1">
-                <a:latin typeface="Arial" panose="020B0604020202020204" pitchFamily="34" charset="0"/>
-              </a:rPr>
-              <a:t>x</a:t>
-            </a:r>
-            <a:r>
-              <a:rPr lang="en-US" altLang="de-DE" sz="1800" dirty="0" err="1">
-                <a:solidFill>
-                  <a:srgbClr val="FF0000"/>
-                </a:solidFill>
-                <a:latin typeface="Arial" panose="020B0604020202020204" pitchFamily="34" charset="0"/>
-              </a:rPr>
-              <a:t>:x</a:t>
-            </a:r>
-            <a:r>
-              <a:rPr lang="en-US" altLang="de-DE" sz="1800" dirty="0">
-                <a:solidFill>
-                  <a:srgbClr val="FF0000"/>
-                </a:solidFill>
-                <a:latin typeface="Arial" panose="020B0604020202020204" pitchFamily="34" charset="0"/>
-              </a:rPr>
-              <a:t>}"</a:t>
-            </a:r>
-            <a:r>
-              <a:rPr lang="en-US" altLang="de-DE" sz="1800" dirty="0">
-                <a:latin typeface="Arial" panose="020B0604020202020204" pitchFamily="34" charset="0"/>
-              </a:rPr>
-              <a:t>, x);	</a:t>
-            </a:r>
-            <a:r>
-              <a:rPr lang="en-US" altLang="de-DE" sz="1800" dirty="0">
-                <a:latin typeface="Courier New" panose="02070309020205020404" pitchFamily="49" charset="0"/>
-              </a:rPr>
-              <a:t>11</a:t>
-            </a:r>
             <a:endParaRPr lang="en-US" altLang="de-DE" sz="1800" dirty="0">
-              <a:latin typeface="Arial" panose="020B0604020202020204" pitchFamily="34" charset="0"/>
+              <a:latin typeface="Consolas" panose="020B0609020204030204" pitchFamily="49" charset="0"/>
             </a:endParaRPr>
-          </a:p>
-          <a:p>
-            <a:r>
-              <a:rPr lang="en-US" altLang="de-DE" sz="1800" dirty="0" err="1">
-                <a:latin typeface="Arial" panose="020B0604020202020204" pitchFamily="34" charset="0"/>
-              </a:rPr>
-              <a:t>Console.WriteLine</a:t>
-            </a:r>
-            <a:r>
-              <a:rPr lang="en-US" altLang="de-DE" sz="1800" dirty="0">
-                <a:latin typeface="Arial" panose="020B0604020202020204" pitchFamily="34" charset="0"/>
-              </a:rPr>
-              <a:t>(</a:t>
-            </a:r>
-            <a:r>
-              <a:rPr lang="en-US" altLang="de-DE" sz="1800" dirty="0"/>
-              <a:t>$</a:t>
-            </a:r>
-            <a:r>
-              <a:rPr lang="en-US" altLang="de-DE" sz="1800" dirty="0">
-                <a:solidFill>
-                  <a:srgbClr val="FF0000"/>
-                </a:solidFill>
-                <a:latin typeface="Arial" panose="020B0604020202020204" pitchFamily="34" charset="0"/>
-              </a:rPr>
-              <a:t>"{</a:t>
-            </a:r>
-            <a:r>
-              <a:rPr lang="en-US" altLang="de-DE" sz="1800" dirty="0">
-                <a:latin typeface="Arial" panose="020B0604020202020204" pitchFamily="34" charset="0"/>
-              </a:rPr>
-              <a:t>x</a:t>
-            </a:r>
-            <a:r>
-              <a:rPr lang="en-US" altLang="de-DE" sz="1800" dirty="0">
-                <a:solidFill>
-                  <a:srgbClr val="FF0000"/>
-                </a:solidFill>
-                <a:latin typeface="Arial" panose="020B0604020202020204" pitchFamily="34" charset="0"/>
-              </a:rPr>
-              <a:t>:x4}"</a:t>
-            </a:r>
-            <a:r>
-              <a:rPr lang="en-US" altLang="de-DE" sz="1800" dirty="0">
-                <a:latin typeface="Arial" panose="020B0604020202020204" pitchFamily="34" charset="0"/>
-              </a:rPr>
-              <a:t>, x);	</a:t>
-            </a:r>
-            <a:r>
-              <a:rPr lang="en-US" altLang="de-DE" sz="1800" dirty="0">
-                <a:latin typeface="Courier New" panose="02070309020205020404" pitchFamily="49" charset="0"/>
-              </a:rPr>
-              <a:t>0011</a:t>
-            </a:r>
           </a:p>
         </p:txBody>
       </p:sp>
@@ -13033,124 +14116,9 @@
             </a:lvl9pPr>
           </a:lstStyle>
           <a:p>
-            <a:r>
-              <a:rPr lang="en-US" altLang="de-DE" sz="1800" dirty="0" err="1">
-                <a:latin typeface="Arial" panose="020B0604020202020204" pitchFamily="34" charset="0"/>
-              </a:rPr>
-              <a:t>Console.WriteLine</a:t>
-            </a:r>
-            <a:r>
-              <a:rPr lang="en-US" altLang="de-DE" sz="1800" dirty="0">
-                <a:latin typeface="Arial" panose="020B0604020202020204" pitchFamily="34" charset="0"/>
-              </a:rPr>
-              <a:t>(</a:t>
-            </a:r>
-            <a:r>
-              <a:rPr lang="en-US" altLang="de-DE" sz="1800" dirty="0"/>
-              <a:t>$</a:t>
-            </a:r>
-            <a:r>
-              <a:rPr lang="en-US" altLang="de-DE" sz="1800" dirty="0">
-                <a:solidFill>
-                  <a:srgbClr val="FF0000"/>
-                </a:solidFill>
-                <a:latin typeface="Arial" panose="020B0604020202020204" pitchFamily="34" charset="0"/>
-              </a:rPr>
-              <a:t>"{</a:t>
-            </a:r>
-            <a:r>
-              <a:rPr lang="en-US" altLang="de-DE" sz="1800" dirty="0" err="1">
-                <a:latin typeface="Arial" panose="020B0604020202020204" pitchFamily="34" charset="0"/>
-              </a:rPr>
-              <a:t>x</a:t>
-            </a:r>
-            <a:r>
-              <a:rPr lang="en-US" altLang="de-DE" sz="1800" dirty="0" err="1">
-                <a:solidFill>
-                  <a:srgbClr val="FF0000"/>
-                </a:solidFill>
-                <a:latin typeface="Arial" panose="020B0604020202020204" pitchFamily="34" charset="0"/>
-              </a:rPr>
-              <a:t>:E</a:t>
-            </a:r>
-            <a:r>
-              <a:rPr lang="en-US" altLang="de-DE" sz="1800" dirty="0">
-                <a:solidFill>
-                  <a:srgbClr val="FF0000"/>
-                </a:solidFill>
-                <a:latin typeface="Arial" panose="020B0604020202020204" pitchFamily="34" charset="0"/>
-              </a:rPr>
-              <a:t>}"</a:t>
-            </a:r>
-            <a:r>
-              <a:rPr lang="en-US" altLang="de-DE" sz="1800" dirty="0">
-                <a:latin typeface="Arial" panose="020B0604020202020204" pitchFamily="34" charset="0"/>
-              </a:rPr>
-              <a:t>, x);	</a:t>
-            </a:r>
-            <a:r>
-              <a:rPr lang="en-US" altLang="de-DE" sz="1800" dirty="0">
-                <a:latin typeface="Courier New" panose="02070309020205020404" pitchFamily="49" charset="0"/>
-              </a:rPr>
-              <a:t>1.700000E+001</a:t>
-            </a:r>
             <a:endParaRPr lang="en-US" altLang="de-DE" sz="1800" dirty="0">
-              <a:latin typeface="Arial" panose="020B0604020202020204" pitchFamily="34" charset="0"/>
+              <a:latin typeface="Consolas" panose="020B0609020204030204" pitchFamily="49" charset="0"/>
             </a:endParaRPr>
-          </a:p>
-          <a:p>
-            <a:r>
-              <a:rPr lang="en-US" altLang="de-DE" sz="1800" dirty="0" err="1">
-                <a:latin typeface="Arial" panose="020B0604020202020204" pitchFamily="34" charset="0"/>
-              </a:rPr>
-              <a:t>Console.WriteLine</a:t>
-            </a:r>
-            <a:r>
-              <a:rPr lang="en-US" altLang="de-DE" sz="1800" dirty="0">
-                <a:latin typeface="Arial" panose="020B0604020202020204" pitchFamily="34" charset="0"/>
-              </a:rPr>
-              <a:t>(</a:t>
-            </a:r>
-            <a:r>
-              <a:rPr lang="en-US" altLang="de-DE" sz="1800" dirty="0"/>
-              <a:t>$</a:t>
-            </a:r>
-            <a:r>
-              <a:rPr lang="en-US" altLang="de-DE" sz="1800" dirty="0">
-                <a:solidFill>
-                  <a:srgbClr val="FF0000"/>
-                </a:solidFill>
-                <a:latin typeface="Arial" panose="020B0604020202020204" pitchFamily="34" charset="0"/>
-              </a:rPr>
-              <a:t>"{</a:t>
-            </a:r>
-            <a:r>
-              <a:rPr lang="en-US" altLang="de-DE" sz="1800" dirty="0">
-                <a:latin typeface="Arial" panose="020B0604020202020204" pitchFamily="34" charset="0"/>
-              </a:rPr>
-              <a:t>x</a:t>
-            </a:r>
-            <a:r>
-              <a:rPr lang="en-US" altLang="de-DE" sz="1800" dirty="0">
-                <a:solidFill>
-                  <a:srgbClr val="FF0000"/>
-                </a:solidFill>
-                <a:latin typeface="Arial" panose="020B0604020202020204" pitchFamily="34" charset="0"/>
-              </a:rPr>
-              <a:t>:e1}"</a:t>
-            </a:r>
-            <a:r>
-              <a:rPr lang="en-US" altLang="de-DE" sz="1800" dirty="0">
-                <a:latin typeface="Arial" panose="020B0604020202020204" pitchFamily="34" charset="0"/>
-              </a:rPr>
-              <a:t>, x);	</a:t>
-            </a:r>
-            <a:r>
-              <a:rPr lang="en-US" altLang="de-DE" sz="1800" dirty="0">
-                <a:latin typeface="Courier New" panose="02070309020205020404" pitchFamily="49" charset="0"/>
-              </a:rPr>
-              <a:t>1.7e+001</a:t>
-            </a:r>
           </a:p>
         </p:txBody>
       </p:sp>
@@ -13322,124 +14290,9 @@
             </a:lvl9pPr>
           </a:lstStyle>
           <a:p>
-            <a:r>
-              <a:rPr lang="en-US" altLang="de-DE" sz="1800" dirty="0" err="1">
-                <a:latin typeface="Arial" panose="020B0604020202020204" pitchFamily="34" charset="0"/>
-              </a:rPr>
-              <a:t>Console.WriteLine</a:t>
-            </a:r>
-            <a:r>
-              <a:rPr lang="en-US" altLang="de-DE" sz="1800" dirty="0">
-                <a:latin typeface="Arial" panose="020B0604020202020204" pitchFamily="34" charset="0"/>
-              </a:rPr>
-              <a:t>(</a:t>
-            </a:r>
-            <a:r>
-              <a:rPr lang="en-US" altLang="de-DE" sz="1800" dirty="0"/>
-              <a:t>$</a:t>
-            </a:r>
-            <a:r>
-              <a:rPr lang="en-US" altLang="de-DE" sz="1800" dirty="0">
-                <a:solidFill>
-                  <a:srgbClr val="FF0000"/>
-                </a:solidFill>
-                <a:latin typeface="Arial" panose="020B0604020202020204" pitchFamily="34" charset="0"/>
-              </a:rPr>
-              <a:t>"{</a:t>
-            </a:r>
-            <a:r>
-              <a:rPr lang="en-US" altLang="de-DE" sz="1800" dirty="0" err="1">
-                <a:latin typeface="Arial" panose="020B0604020202020204" pitchFamily="34" charset="0"/>
-              </a:rPr>
-              <a:t>x</a:t>
-            </a:r>
-            <a:r>
-              <a:rPr lang="en-US" altLang="de-DE" sz="1800" dirty="0" err="1">
-                <a:solidFill>
-                  <a:srgbClr val="FF0000"/>
-                </a:solidFill>
-                <a:latin typeface="Arial" panose="020B0604020202020204" pitchFamily="34" charset="0"/>
-              </a:rPr>
-              <a:t>:f</a:t>
-            </a:r>
-            <a:r>
-              <a:rPr lang="en-US" altLang="de-DE" sz="1800" dirty="0">
-                <a:solidFill>
-                  <a:srgbClr val="FF0000"/>
-                </a:solidFill>
-                <a:latin typeface="Arial" panose="020B0604020202020204" pitchFamily="34" charset="0"/>
-              </a:rPr>
-              <a:t>}"</a:t>
-            </a:r>
-            <a:r>
-              <a:rPr lang="en-US" altLang="de-DE" sz="1800" dirty="0">
-                <a:latin typeface="Arial" panose="020B0604020202020204" pitchFamily="34" charset="0"/>
-              </a:rPr>
-              <a:t>, x);	</a:t>
-            </a:r>
-            <a:r>
-              <a:rPr lang="en-US" altLang="de-DE" sz="1800" dirty="0">
-                <a:latin typeface="Courier New" panose="02070309020205020404" pitchFamily="49" charset="0"/>
-              </a:rPr>
-              <a:t>17.00</a:t>
-            </a:r>
             <a:endParaRPr lang="en-US" altLang="de-DE" sz="1800" dirty="0">
-              <a:latin typeface="Arial" panose="020B0604020202020204" pitchFamily="34" charset="0"/>
+              <a:latin typeface="Consolas" panose="020B0609020204030204" pitchFamily="49" charset="0"/>
             </a:endParaRPr>
-          </a:p>
-          <a:p>
-            <a:r>
-              <a:rPr lang="en-US" altLang="de-DE" sz="1800" dirty="0" err="1">
-                <a:latin typeface="Arial" panose="020B0604020202020204" pitchFamily="34" charset="0"/>
-              </a:rPr>
-              <a:t>Console.WriteLine</a:t>
-            </a:r>
-            <a:r>
-              <a:rPr lang="en-US" altLang="de-DE" sz="1800" dirty="0">
-                <a:latin typeface="Arial" panose="020B0604020202020204" pitchFamily="34" charset="0"/>
-              </a:rPr>
-              <a:t>(</a:t>
-            </a:r>
-            <a:r>
-              <a:rPr lang="en-US" altLang="de-DE" sz="1800" dirty="0"/>
-              <a:t>$</a:t>
-            </a:r>
-            <a:r>
-              <a:rPr lang="en-US" altLang="de-DE" sz="1800" dirty="0">
-                <a:solidFill>
-                  <a:srgbClr val="FF0000"/>
-                </a:solidFill>
-                <a:latin typeface="Arial" panose="020B0604020202020204" pitchFamily="34" charset="0"/>
-              </a:rPr>
-              <a:t>"{</a:t>
-            </a:r>
-            <a:r>
-              <a:rPr lang="en-US" altLang="de-DE" sz="1800" dirty="0">
-                <a:latin typeface="Arial" panose="020B0604020202020204" pitchFamily="34" charset="0"/>
-              </a:rPr>
-              <a:t>x</a:t>
-            </a:r>
-            <a:r>
-              <a:rPr lang="en-US" altLang="de-DE" sz="1800" dirty="0">
-                <a:solidFill>
-                  <a:srgbClr val="FF0000"/>
-                </a:solidFill>
-                <a:latin typeface="Arial" panose="020B0604020202020204" pitchFamily="34" charset="0"/>
-              </a:rPr>
-              <a:t>:f1}"</a:t>
-            </a:r>
-            <a:r>
-              <a:rPr lang="en-US" altLang="de-DE" sz="1800" dirty="0">
-                <a:latin typeface="Arial" panose="020B0604020202020204" pitchFamily="34" charset="0"/>
-              </a:rPr>
-              <a:t>, x);	</a:t>
-            </a:r>
-            <a:r>
-              <a:rPr lang="en-US" altLang="de-DE" sz="1800" dirty="0">
-                <a:latin typeface="Courier New" panose="02070309020205020404" pitchFamily="49" charset="0"/>
-              </a:rPr>
-              <a:t>17.0</a:t>
-            </a:r>
           </a:p>
         </p:txBody>
       </p:sp>
@@ -13611,124 +14464,189 @@
             </a:lvl9pPr>
           </a:lstStyle>
           <a:p>
-            <a:r>
-              <a:rPr lang="en-US" altLang="de-DE" sz="1800" dirty="0" err="1">
-                <a:latin typeface="Arial" panose="020B0604020202020204" pitchFamily="34" charset="0"/>
-              </a:rPr>
-              <a:t>Console.WriteLine</a:t>
-            </a:r>
-            <a:r>
-              <a:rPr lang="en-US" altLang="de-DE" sz="1800" dirty="0">
-                <a:latin typeface="Arial" panose="020B0604020202020204" pitchFamily="34" charset="0"/>
-              </a:rPr>
-              <a:t>(</a:t>
-            </a:r>
-            <a:r>
-              <a:rPr lang="en-US" altLang="de-DE" sz="1800" dirty="0"/>
-              <a:t>$</a:t>
-            </a:r>
-            <a:r>
-              <a:rPr lang="en-US" altLang="de-DE" sz="1800" dirty="0">
-                <a:solidFill>
-                  <a:srgbClr val="FF0000"/>
-                </a:solidFill>
-                <a:latin typeface="Arial" panose="020B0604020202020204" pitchFamily="34" charset="0"/>
-              </a:rPr>
-              <a:t>"{</a:t>
-            </a:r>
-            <a:r>
-              <a:rPr lang="en-US" altLang="de-DE" sz="1800" dirty="0" err="1">
-                <a:latin typeface="Arial" panose="020B0604020202020204" pitchFamily="34" charset="0"/>
-              </a:rPr>
-              <a:t>x</a:t>
-            </a:r>
-            <a:r>
-              <a:rPr lang="en-US" altLang="de-DE" sz="1800" dirty="0" err="1">
-                <a:solidFill>
-                  <a:srgbClr val="FF0000"/>
-                </a:solidFill>
-                <a:latin typeface="Arial" panose="020B0604020202020204" pitchFamily="34" charset="0"/>
-              </a:rPr>
-              <a:t>:d</a:t>
-            </a:r>
-            <a:r>
-              <a:rPr lang="en-US" altLang="de-DE" sz="1800" dirty="0">
-                <a:solidFill>
-                  <a:srgbClr val="FF0000"/>
-                </a:solidFill>
-                <a:latin typeface="Arial" panose="020B0604020202020204" pitchFamily="34" charset="0"/>
-              </a:rPr>
-              <a:t>}"</a:t>
-            </a:r>
-            <a:r>
-              <a:rPr lang="en-US" altLang="de-DE" sz="1800" dirty="0">
-                <a:latin typeface="Arial" panose="020B0604020202020204" pitchFamily="34" charset="0"/>
-              </a:rPr>
-              <a:t>,);	</a:t>
-            </a:r>
-            <a:r>
-              <a:rPr lang="en-US" altLang="de-DE" sz="1800" dirty="0">
-                <a:latin typeface="Courier New" panose="02070309020205020404" pitchFamily="49" charset="0"/>
-              </a:rPr>
-              <a:t>17</a:t>
-            </a:r>
             <a:endParaRPr lang="en-US" altLang="de-DE" sz="1800" dirty="0">
-              <a:latin typeface="Arial" panose="020B0604020202020204" pitchFamily="34" charset="0"/>
+              <a:latin typeface="Consolas" panose="020B0609020204030204" pitchFamily="49" charset="0"/>
             </a:endParaRPr>
           </a:p>
-          <a:p>
-            <a:r>
-              <a:rPr lang="en-US" altLang="de-DE" sz="1800" dirty="0" err="1">
-                <a:latin typeface="Arial" panose="020B0604020202020204" pitchFamily="34" charset="0"/>
-              </a:rPr>
-              <a:t>Console.WriteLine</a:t>
-            </a:r>
-            <a:r>
-              <a:rPr lang="en-US" altLang="de-DE" sz="1800" dirty="0">
-                <a:latin typeface="Arial" panose="020B0604020202020204" pitchFamily="34" charset="0"/>
-              </a:rPr>
-              <a:t>(</a:t>
-            </a:r>
-            <a:r>
-              <a:rPr lang="en-US" altLang="de-DE" sz="1800" dirty="0"/>
-              <a:t>$</a:t>
-            </a:r>
-            <a:r>
-              <a:rPr lang="en-US" altLang="de-DE" sz="1800" dirty="0">
-                <a:solidFill>
-                  <a:srgbClr val="FF0000"/>
-                </a:solidFill>
-                <a:latin typeface="Arial" panose="020B0604020202020204" pitchFamily="34" charset="0"/>
-              </a:rPr>
-              <a:t>"{</a:t>
-            </a:r>
-            <a:r>
-              <a:rPr lang="en-US" altLang="de-DE" sz="1800" dirty="0">
-                <a:latin typeface="Arial" panose="020B0604020202020204" pitchFamily="34" charset="0"/>
-              </a:rPr>
-              <a:t>x</a:t>
-            </a:r>
-            <a:r>
-              <a:rPr lang="en-US" altLang="de-DE" sz="1800" dirty="0">
-                <a:solidFill>
-                  <a:srgbClr val="FF0000"/>
-                </a:solidFill>
-                <a:latin typeface="Arial" panose="020B0604020202020204" pitchFamily="34" charset="0"/>
-              </a:rPr>
-              <a:t>,5:d3}"</a:t>
-            </a:r>
-            <a:r>
-              <a:rPr lang="en-US" altLang="de-DE" sz="1800" dirty="0">
-                <a:latin typeface="Arial" panose="020B0604020202020204" pitchFamily="34" charset="0"/>
-              </a:rPr>
-              <a:t>,);	</a:t>
-            </a:r>
-            <a:r>
-              <a:rPr lang="en-US" altLang="de-DE" sz="1800" dirty="0">
-                <a:latin typeface="Courier New" panose="02070309020205020404" pitchFamily="49" charset="0"/>
-              </a:rPr>
-              <a:t>  017</a:t>
-            </a:r>
+        </p:txBody>
+      </p:sp>
+      <p:sp>
+        <p:nvSpPr>
+          <p:cNvPr id="9" name="Rectangle 4">
+            <a:extLst>
+              <a:ext uri="{FF2B5EF4-FFF2-40B4-BE49-F238E27FC236}">
+                <a16:creationId xmlns:a16="http://schemas.microsoft.com/office/drawing/2014/main" id="{F8CD2A78-C25C-4C2A-B84C-CB20999DF119}"/>
+              </a:ext>
+            </a:extLst>
+          </p:cNvPr>
+          <p:cNvSpPr>
+            <a:spLocks noChangeArrowheads="1"/>
+          </p:cNvSpPr>
+          <p:nvPr/>
+        </p:nvSpPr>
+        <p:spPr bwMode="auto">
+          <a:xfrm>
+            <a:off x="685800" y="5578343"/>
+            <a:ext cx="7772400" cy="520700"/>
+          </a:xfrm>
+          <a:prstGeom prst="rect">
+            <a:avLst/>
+          </a:prstGeom>
+          <a:noFill/>
+          <a:ln>
+            <a:noFill/>
+          </a:ln>
+          <a:extLst>
+            <a:ext uri="{909E8E84-426E-40DD-AFC4-6F175D3DCCD1}">
+              <a14:hiddenFill xmlns:a14="http://schemas.microsoft.com/office/drawing/2010/main">
+                <a:solidFill>
+                  <a:srgbClr val="FFFFFF"/>
+                </a:solidFill>
+              </a14:hiddenFill>
+            </a:ext>
+            <a:ext uri="{91240B29-F687-4F45-9708-019B960494DF}">
+              <a14:hiddenLine xmlns:a14="http://schemas.microsoft.com/office/drawing/2010/main" w="9525">
+                <a:solidFill>
+                  <a:srgbClr val="000000"/>
+                </a:solidFill>
+                <a:miter lim="800000"/>
+                <a:headEnd/>
+                <a:tailEnd/>
+              </a14:hiddenLine>
+            </a:ext>
+          </a:extLst>
+        </p:spPr>
+        <p:txBody>
+          <a:bodyPr/>
+          <a:lstStyle>
+            <a:lvl1pPr marL="342900" indent="-342900">
+              <a:tabLst>
+                <a:tab pos="3657600" algn="l"/>
+              </a:tabLst>
+              <a:defRPr sz="1600">
+                <a:solidFill>
+                  <a:schemeClr val="tx1"/>
+                </a:solidFill>
+                <a:latin typeface="Times New Roman" panose="02020603050405020304" pitchFamily="18" charset="0"/>
+              </a:defRPr>
+            </a:lvl1pPr>
+            <a:lvl2pPr marL="742950" indent="-285750">
+              <a:tabLst>
+                <a:tab pos="3657600" algn="l"/>
+              </a:tabLst>
+              <a:defRPr sz="1600">
+                <a:solidFill>
+                  <a:schemeClr val="tx1"/>
+                </a:solidFill>
+                <a:latin typeface="Times New Roman" panose="02020603050405020304" pitchFamily="18" charset="0"/>
+              </a:defRPr>
+            </a:lvl2pPr>
+            <a:lvl3pPr marL="1143000" indent="-228600">
+              <a:tabLst>
+                <a:tab pos="3657600" algn="l"/>
+              </a:tabLst>
+              <a:defRPr sz="1600">
+                <a:solidFill>
+                  <a:schemeClr val="tx1"/>
+                </a:solidFill>
+                <a:latin typeface="Times New Roman" panose="02020603050405020304" pitchFamily="18" charset="0"/>
+              </a:defRPr>
+            </a:lvl3pPr>
+            <a:lvl4pPr marL="1600200" indent="-228600">
+              <a:tabLst>
+                <a:tab pos="3657600" algn="l"/>
+              </a:tabLst>
+              <a:defRPr sz="1600">
+                <a:solidFill>
+                  <a:schemeClr val="tx1"/>
+                </a:solidFill>
+                <a:latin typeface="Times New Roman" panose="02020603050405020304" pitchFamily="18" charset="0"/>
+              </a:defRPr>
+            </a:lvl4pPr>
+            <a:lvl5pPr marL="2057400" indent="-228600">
+              <a:tabLst>
+                <a:tab pos="3657600" algn="l"/>
+              </a:tabLst>
+              <a:defRPr sz="1600">
+                <a:solidFill>
+                  <a:schemeClr val="tx1"/>
+                </a:solidFill>
+                <a:latin typeface="Times New Roman" panose="02020603050405020304" pitchFamily="18" charset="0"/>
+              </a:defRPr>
+            </a:lvl5pPr>
+            <a:lvl6pPr marL="2514600" indent="-228600" eaLnBrk="0" fontAlgn="base" hangingPunct="0">
+              <a:spcBef>
+                <a:spcPct val="0"/>
+              </a:spcBef>
+              <a:spcAft>
+                <a:spcPct val="0"/>
+              </a:spcAft>
+              <a:tabLst>
+                <a:tab pos="3657600" algn="l"/>
+              </a:tabLst>
+              <a:defRPr sz="1600">
+                <a:solidFill>
+                  <a:schemeClr val="tx1"/>
+                </a:solidFill>
+                <a:latin typeface="Times New Roman" panose="02020603050405020304" pitchFamily="18" charset="0"/>
+              </a:defRPr>
+            </a:lvl6pPr>
+            <a:lvl7pPr marL="2971800" indent="-228600" eaLnBrk="0" fontAlgn="base" hangingPunct="0">
+              <a:spcBef>
+                <a:spcPct val="0"/>
+              </a:spcBef>
+              <a:spcAft>
+                <a:spcPct val="0"/>
+              </a:spcAft>
+              <a:tabLst>
+                <a:tab pos="3657600" algn="l"/>
+              </a:tabLst>
+              <a:defRPr sz="1600">
+                <a:solidFill>
+                  <a:schemeClr val="tx1"/>
+                </a:solidFill>
+                <a:latin typeface="Times New Roman" panose="02020603050405020304" pitchFamily="18" charset="0"/>
+              </a:defRPr>
+            </a:lvl7pPr>
+            <a:lvl8pPr marL="3429000" indent="-228600" eaLnBrk="0" fontAlgn="base" hangingPunct="0">
+              <a:spcBef>
+                <a:spcPct val="0"/>
+              </a:spcBef>
+              <a:spcAft>
+                <a:spcPct val="0"/>
+              </a:spcAft>
+              <a:tabLst>
+                <a:tab pos="3657600" algn="l"/>
+              </a:tabLst>
+              <a:defRPr sz="1600">
+                <a:solidFill>
+                  <a:schemeClr val="tx1"/>
+                </a:solidFill>
+                <a:latin typeface="Times New Roman" panose="02020603050405020304" pitchFamily="18" charset="0"/>
+              </a:defRPr>
+            </a:lvl8pPr>
+            <a:lvl9pPr marL="3886200" indent="-228600" eaLnBrk="0" fontAlgn="base" hangingPunct="0">
+              <a:spcBef>
+                <a:spcPct val="0"/>
+              </a:spcBef>
+              <a:spcAft>
+                <a:spcPct val="0"/>
+              </a:spcAft>
+              <a:tabLst>
+                <a:tab pos="3657600" algn="l"/>
+              </a:tabLst>
+              <a:defRPr sz="1600">
+                <a:solidFill>
+                  <a:schemeClr val="tx1"/>
+                </a:solidFill>
+                <a:latin typeface="Times New Roman" panose="02020603050405020304" pitchFamily="18" charset="0"/>
+              </a:defRPr>
+            </a:lvl9pPr>
+          </a:lstStyle>
+          <a:p>
+            <a:endParaRPr lang="en-US" altLang="de-DE" sz="1800" dirty="0">
+              <a:latin typeface="Consolas" panose="020B0609020204030204" pitchFamily="49" charset="0"/>
+            </a:endParaRPr>
           </a:p>
         </p:txBody>
       </p:sp>
@@ -13763,10 +14681,15 @@
                             </p:stCondLst>
                             <p:childTnLst>
                               <p:par>
-                                <p:cTn id="5" presetID="1" presetClass="entr" presetSubtype="0" fill="hold" grpId="0" nodeType="clickEffect">
+                                <p:cTn id="5" presetID="1" presetClass="entr" presetSubtype="0" fill="hold" grpId="0" nodeType="clickEffect" nodePh="1">
                                   <p:stCondLst>
                                     <p:cond delay="0"/>
                                   </p:stCondLst>
+                                  <p:endCondLst>
+                                    <p:cond evt="begin" delay="0">
+                                      <p:tn val="5"/>
+                                    </p:cond>
+                                  </p:endCondLst>
                                   <p:childTnLst>
                                     <p:set>
                                       <p:cBhvr>
@@ -13808,10 +14731,15 @@
                             </p:stCondLst>
                             <p:childTnLst>
                               <p:par>
-                                <p:cTn id="9" presetID="1" presetClass="entr" presetSubtype="0" fill="hold" grpId="0" nodeType="clickEffect">
+                                <p:cTn id="9" presetID="1" presetClass="entr" presetSubtype="0" fill="hold" grpId="0" nodeType="clickEffect" nodePh="1">
                                   <p:stCondLst>
                                     <p:cond delay="0"/>
                                   </p:stCondLst>
+                                  <p:endCondLst>
+                                    <p:cond evt="begin" delay="0">
+                                      <p:tn val="9"/>
+                                    </p:cond>
+                                  </p:endCondLst>
                                   <p:childTnLst>
                                     <p:set>
                                       <p:cBhvr>
@@ -13853,10 +14781,15 @@
                             </p:stCondLst>
                             <p:childTnLst>
                               <p:par>
-                                <p:cTn id="13" presetID="1" presetClass="entr" presetSubtype="0" fill="hold" grpId="0" nodeType="clickEffect">
+                                <p:cTn id="13" presetID="1" presetClass="entr" presetSubtype="0" fill="hold" grpId="0" nodeType="clickEffect" nodePh="1">
                                   <p:stCondLst>
                                     <p:cond delay="0"/>
                                   </p:stCondLst>
+                                  <p:endCondLst>
+                                    <p:cond evt="begin" delay="0">
+                                      <p:tn val="13"/>
+                                    </p:cond>
+                                  </p:endCondLst>
                                   <p:childTnLst>
                                     <p:set>
                                       <p:cBhvr>
@@ -13898,10 +14831,15 @@
                             </p:stCondLst>
                             <p:childTnLst>
                               <p:par>
-                                <p:cTn id="17" presetID="1" presetClass="entr" presetSubtype="0" fill="hold" grpId="0" nodeType="clickEffect">
+                                <p:cTn id="17" presetID="1" presetClass="entr" presetSubtype="0" fill="hold" grpId="0" nodeType="clickEffect" nodePh="1">
                                   <p:stCondLst>
                                     <p:cond delay="0"/>
                                   </p:stCondLst>
+                                  <p:endCondLst>
+                                    <p:cond evt="begin" delay="0">
+                                      <p:tn val="17"/>
+                                    </p:cond>
+                                  </p:endCondLst>
                                   <p:childTnLst>
                                     <p:set>
                                       <p:cBhvr>
@@ -13912,6 +14850,56 @@
                                         </p:cTn>
                                         <p:tgtEl>
                                           <p:spTgt spid="5"/>
+                                        </p:tgtEl>
+                                        <p:attrNameLst>
+                                          <p:attrName>style.visibility</p:attrName>
+                                        </p:attrNameLst>
+                                      </p:cBhvr>
+                                      <p:to>
+                                        <p:strVal val="visible"/>
+                                      </p:to>
+                                    </p:set>
+                                  </p:childTnLst>
+                                </p:cTn>
+                              </p:par>
+                            </p:childTnLst>
+                          </p:cTn>
+                        </p:par>
+                      </p:childTnLst>
+                    </p:cTn>
+                  </p:par>
+                  <p:par>
+                    <p:cTn id="19" fill="hold">
+                      <p:stCondLst>
+                        <p:cond delay="indefinite"/>
+                      </p:stCondLst>
+                      <p:childTnLst>
+                        <p:par>
+                          <p:cTn id="20" fill="hold">
+                            <p:stCondLst>
+                              <p:cond delay="0"/>
+                            </p:stCondLst>
+                            <p:childTnLst>
+                              <p:par>
+                                <p:cTn id="21" presetID="1" presetClass="entr" presetSubtype="0" fill="hold" grpId="0" nodeType="clickEffect" nodePh="1">
+                                  <p:stCondLst>
+                                    <p:cond delay="0"/>
+                                  </p:stCondLst>
+                                  <p:endCondLst>
+                                    <p:cond evt="begin" delay="0">
+                                      <p:tn val="21"/>
+                                    </p:cond>
+                                  </p:endCondLst>
+                                  <p:childTnLst>
+                                    <p:set>
+                                      <p:cBhvr>
+                                        <p:cTn id="22" dur="1" fill="hold">
+                                          <p:stCondLst>
+                                            <p:cond delay="499"/>
+                                          </p:stCondLst>
+                                        </p:cTn>
+                                        <p:tgtEl>
+                                          <p:spTgt spid="9"/>
                                         </p:tgtEl>
                                         <p:attrNameLst>
                                           <p:attrName>style.visibility</p:attrName>
@@ -13956,6 +14944,7 @@
       <p:bldP spid="6" grpId="0" autoUpdateAnimBg="0"/>
       <p:bldP spid="7" grpId="0" autoUpdateAnimBg="0"/>
       <p:bldP spid="8" grpId="0" autoUpdateAnimBg="0"/>
+      <p:bldP spid="9" grpId="0" autoUpdateAnimBg="0"/>
     </p:bldLst>
   </p:timing>
 </p:sld>

</xml_diff>